<commit_message>
docs(video): sync script to user-edited deck; add slide 9 roadmap outro
Co-Authored-By: Claude Fable 5 <noreply@anthropic.com>
</commit_message>
<xml_diff>
--- a/planning/video-deck.pptx
+++ b/planning/video-deck.pptx
@@ -4,6 +4,9 @@
   <p:sldMasterIdLst>
     <p:sldMasterId id="2147483648" r:id="rId1"/>
   </p:sldMasterIdLst>
+  <p:notesMasterIdLst>
+    <p:notesMasterId r:id="rId11"/>
+  </p:notesMasterIdLst>
   <p:sldIdLst>
     <p:sldId id="256" r:id="rId2"/>
     <p:sldId id="257" r:id="rId3"/>
@@ -13,12 +16,10 @@
     <p:sldId id="261" r:id="rId7"/>
     <p:sldId id="262" r:id="rId8"/>
     <p:sldId id="263" r:id="rId9"/>
+    <p:sldId id="264" r:id="rId10"/>
   </p:sldIdLst>
-  <p:notesMasterIdLst>
-    <p:notesMasterId r:id="rId10"/>
-  </p:notesMasterIdLst>
-  <p:sldSz cx="12188952" cy="6858000"/>
-  <p:notesSz cx="6858000" cy="12188952"/>
+  <p:sldSz cx="12188825" cy="6858000"/>
+  <p:notesSz cx="6858000" cy="12188825"/>
   <p:defaultTextStyle>
     <a:lvl1pPr marL="0" algn="l" defTabSz="914400" rtl="0" eaLnBrk="1" latinLnBrk="0" hangingPunct="1">
       <a:defRPr sz="1800" kern="1200">
@@ -111,6 +112,11 @@
       </a:defRPr>
     </a:lvl9pPr>
   </p:defaultTextStyle>
+  <p:extLst>
+    <p:ext uri="{EFAFB233-063F-42B5-8137-9DF3F51BA10A}">
+      <p15:sldGuideLst xmlns:p15="http://schemas.microsoft.com/office/powerpoint/2012/main"/>
+    </p:ext>
+  </p:extLst>
 </p:presentation>
 </file>
 
@@ -136,234 +142,10 @@
           <a:chExt cx="0" cy="0"/>
         </a:xfrm>
       </p:grpSpPr>
-      <p:sp>
-        <p:nvSpPr>
-          <p:cNvPr id="2" name="Header Placeholder 1"/>
-          <p:cNvSpPr>
-            <a:spLocks noGrp="1"/>
-          </p:cNvSpPr>
-          <p:nvPr>
-            <p:ph type="hdr" sz="quarter"/>
-          </p:nvPr>
-        </p:nvSpPr>
-        <p:spPr>
-          <a:xfrm>
-            <a:off x="0" y="0"/>
-            <a:ext cx="2971800" cy="458788"/>
-          </a:xfrm>
-          <a:prstGeom prst="rect">
-            <a:avLst/>
-          </a:prstGeom>
-        </p:spPr>
-        <p:txBody>
-          <a:bodyPr vert="horz" lIns="91440" tIns="45720" rIns="91440" bIns="45720" rtlCol="0"/>
-          <a:lstStyle>
-            <a:lvl1pPr algn="l">
-              <a:defRPr sz="1200"/>
-            </a:lvl1pPr>
-          </a:lstStyle>
-          <a:p>
-            <a:endParaRPr lang="en-US"/>
-          </a:p>
-        </p:txBody>
-      </p:sp>
-      <p:sp>
-        <p:nvSpPr>
-          <p:cNvPr id="3" name="Date Placeholder 2"/>
-          <p:cNvSpPr>
-            <a:spLocks noGrp="1"/>
-          </p:cNvSpPr>
-          <p:nvPr>
-            <p:ph type="dt" idx="1"/>
-          </p:nvPr>
-        </p:nvSpPr>
-        <p:spPr>
-          <a:xfrm>
-            <a:off x="3884613" y="0"/>
-            <a:ext cx="2971800" cy="458788"/>
-          </a:xfrm>
-          <a:prstGeom prst="rect">
-            <a:avLst/>
-          </a:prstGeom>
-        </p:spPr>
-        <p:txBody>
-          <a:bodyPr vert="horz" lIns="91440" tIns="45720" rIns="91440" bIns="45720" rtlCol="0"/>
-          <a:lstStyle>
-            <a:lvl1pPr algn="r">
-              <a:defRPr sz="1200"/>
-            </a:lvl1pPr>
-          </a:lstStyle>
-          <a:p>
-            <a:fld id="{5282F153-3F37-0F45-9E97-73ACFA13230C}" type="datetimeFigureOut">
-              <a:rPr lang="en-US"/>
-              <a:t>7/23/19</a:t>
-            </a:fld>
-            <a:endParaRPr lang="en-US"/>
-          </a:p>
-        </p:txBody>
-      </p:sp>
-      <p:sp>
-        <p:nvSpPr>
-          <p:cNvPr id="4" name="Slide Image Placeholder 3"/>
-          <p:cNvSpPr>
-            <a:spLocks noGrp="1" noRot="1" noChangeAspect="1"/>
-          </p:cNvSpPr>
-          <p:nvPr>
-            <p:ph type="sldImg" idx="2"/>
-          </p:nvPr>
-        </p:nvSpPr>
-        <p:spPr>
-          <a:xfrm>
-            <a:off x="685800" y="1143000"/>
-            <a:ext cx="5486400" cy="3086100"/>
-          </a:xfrm>
-          <a:prstGeom prst="rect">
-            <a:avLst/>
-          </a:prstGeom>
-          <a:noFill/>
-          <a:ln w="12700">
-            <a:solidFill>
-              <a:prstClr val="black"/>
-            </a:solidFill>
-          </a:ln>
-        </p:spPr>
-        <p:txBody>
-          <a:bodyPr vert="horz" lIns="91440" tIns="45720" rIns="91440" bIns="45720" rtlCol="0" anchor="ctr"/>
-          <a:lstStyle/>
-          <a:p>
-            <a:endParaRPr lang="en-US"/>
-          </a:p>
-        </p:txBody>
-      </p:sp>
-      <p:sp>
-        <p:nvSpPr>
-          <p:cNvPr id="5" name="Notes Placeholder 4"/>
-          <p:cNvSpPr>
-            <a:spLocks noGrp="1"/>
-          </p:cNvSpPr>
-          <p:nvPr>
-            <p:ph type="body" sz="quarter" idx="3"/>
-          </p:nvPr>
-        </p:nvSpPr>
-        <p:spPr>
-          <a:xfrm>
-            <a:off x="685800" y="4400550"/>
-            <a:ext cx="5486400" cy="3600450"/>
-          </a:xfrm>
-          <a:prstGeom prst="rect">
-            <a:avLst/>
-          </a:prstGeom>
-        </p:spPr>
-        <p:txBody>
-          <a:bodyPr vert="horz" lIns="91440" tIns="45720" rIns="91440" bIns="45720" rtlCol="0"/>
-          <a:lstStyle/>
-          <a:p>
-            <a:pPr lvl="0"/>
-            <a:r>
-              <a:rPr lang="en-US"/>
-              <a:t>Click to edit Master text styles</a:t>
-            </a:r>
-          </a:p>
-          <a:p>
-            <a:pPr lvl="1"/>
-            <a:r>
-              <a:rPr lang="en-US"/>
-              <a:t>Second level</a:t>
-            </a:r>
-          </a:p>
-          <a:p>
-            <a:pPr lvl="2"/>
-            <a:r>
-              <a:rPr lang="en-US"/>
-              <a:t>Third level</a:t>
-            </a:r>
-          </a:p>
-          <a:p>
-            <a:pPr lvl="3"/>
-            <a:r>
-              <a:rPr lang="en-US"/>
-              <a:t>Fourth level</a:t>
-            </a:r>
-          </a:p>
-          <a:p>
-            <a:pPr lvl="4"/>
-            <a:r>
-              <a:rPr lang="en-US"/>
-              <a:t>Fifth level</a:t>
-            </a:r>
-          </a:p>
-        </p:txBody>
-      </p:sp>
-      <p:sp>
-        <p:nvSpPr>
-          <p:cNvPr id="6" name="Footer Placeholder 5"/>
-          <p:cNvSpPr>
-            <a:spLocks noGrp="1"/>
-          </p:cNvSpPr>
-          <p:nvPr>
-            <p:ph type="ftr" sz="quarter" idx="4"/>
-          </p:nvPr>
-        </p:nvSpPr>
-        <p:spPr>
-          <a:xfrm>
-            <a:off x="0" y="8685213"/>
-            <a:ext cx="2971800" cy="458787"/>
-          </a:xfrm>
-          <a:prstGeom prst="rect">
-            <a:avLst/>
-          </a:prstGeom>
-        </p:spPr>
-        <p:txBody>
-          <a:bodyPr vert="horz" lIns="91440" tIns="45720" rIns="91440" bIns="45720" rtlCol="0" anchor="b"/>
-          <a:lstStyle>
-            <a:lvl1pPr algn="l">
-              <a:defRPr sz="1200"/>
-            </a:lvl1pPr>
-          </a:lstStyle>
-          <a:p>
-            <a:endParaRPr lang="en-US"/>
-          </a:p>
-        </p:txBody>
-      </p:sp>
-      <p:sp>
-        <p:nvSpPr>
-          <p:cNvPr id="7" name="Slide Number Placeholder 6"/>
-          <p:cNvSpPr>
-            <a:spLocks noGrp="1"/>
-          </p:cNvSpPr>
-          <p:nvPr>
-            <p:ph type="sldNum" sz="quarter" idx="5"/>
-          </p:nvPr>
-        </p:nvSpPr>
-        <p:spPr>
-          <a:xfrm>
-            <a:off x="3884613" y="8685213"/>
-            <a:ext cx="2971800" cy="458787"/>
-          </a:xfrm>
-          <a:prstGeom prst="rect">
-            <a:avLst/>
-          </a:prstGeom>
-        </p:spPr>
-        <p:txBody>
-          <a:bodyPr vert="horz" lIns="91440" tIns="45720" rIns="91440" bIns="45720" rtlCol="0" anchor="b"/>
-          <a:lstStyle>
-            <a:lvl1pPr algn="r">
-              <a:defRPr sz="1200"/>
-            </a:lvl1pPr>
-          </a:lstStyle>
-          <a:p>
-            <a:fld id="{CE5E9CC1-C706-0F49-92D6-E571CC5EEA8F}" type="slidenum">
-              <a:rPr lang="en-US"/>
-              <a:t>‹#›</a:t>
-            </a:fld>
-            <a:endParaRPr lang="en-US"/>
-          </a:p>
-        </p:txBody>
-      </p:sp>
     </p:spTree>
     <p:extLst>
       <p:ext uri="{BB962C8B-B14F-4D97-AF65-F5344CB8AC3E}">
-        <p14:creationId xmlns:p14="http://schemas.microsoft.com/office/powerpoint/2010/main" val="1024086991"/>
+        <p14:creationId xmlns:p14="http://schemas.microsoft.com/office/powerpoint/2010/main" val="2095777269"/>
       </p:ext>
     </p:extLst>
   </p:cSld>
@@ -509,9 +291,8 @@
           <a:p>
             <a:r>
               <a:rPr lang="en-US" dirty="0"/>
-              <a:t>0:00. This is Family-Hub — an agent that runs our household. It plans the weekend, assigns the chores, watches the bills, and does the booking legwork. And here is the thing: it cannot spend our money. Not won't — CAN'T. There is nothing in it that can pay. Running a family is a coordination job nobody applied for — and the reason we don't hand it to an AI is trust. So I built the trust first.</a:t>
-            </a:r>
-            <a:endParaRPr lang="en-US" dirty="0"/>
+              <a:t>0:00. This is Family-Hub — an agent that runs our household. It plans the weekend, assigns the chores, watches the bills, and does the booking legwork. Running a family is a coordination job nobody applied for — and the reason we don't hand it to an AI is trust. So I built the trust first with sensible security architecture and a setup that puts the human/adult back in the loop to make final decisions including but especially around purchase and spending money that the AI is structurally prevented from doing here.</a:t>
+            </a:r>
           </a:p>
         </p:txBody>
       </p:sp>
@@ -599,7 +380,6 @@
               <a:rPr lang="en-US" dirty="0"/>
               <a:t>0:20. The valuable work isn't answering questions — it's multi-step: research pass rules on the live web, check our calendar, draft the itinerary, find the real booking page and gather what its form will ask. That takes an agent that chooses tools and keeps going. But every capability is also blast radius — so the architecture is a safety stack with an agent inside.</a:t>
             </a:r>
-            <a:endParaRPr lang="en-US" dirty="0"/>
           </a:p>
         </p:txBody>
       </p:sp>
@@ -687,7 +467,6 @@
               <a:rPr lang="en-US" dirty="0"/>
               <a:t>0:40. One copilot, two engines. Simple asks run a deterministic harness — the server pre-fetches verified facts: availability, weather, real venues with drive times — and the model reasons over THOSE, so it can't invent a place. Action turns go to an ADK multi-agent concierge: a root router with no tools of its own, delegating to seven specialists, each MCP-filtered to its own slice — the shopping agent literally cannot touch the calendar. Every write carries a server-side risk tier: reversible creates auto-apply, everything destructive stages into Approvals — and there is NO payment tool to call. That invariant is enforced in the MCP layer and proven by tests, not promised by a prompt.</a:t>
             </a:r>
-            <a:endParaRPr lang="en-US" dirty="0"/>
           </a:p>
         </p:txBody>
       </p:sp>
@@ -775,7 +554,6 @@
               <a:rPr lang="en-US" dirty="0"/>
               <a:t>1:10. Everything risky lands in one place: Approvals. The morning agent's proposals, deletes, event suggestions — approve, modify, or dismiss. Booking handoffs open the venue's real page with the details listed beside it — it never fills the form and never pays. And the whole thing stays in its lane: ask it for homework help and it politely declines.</a:t>
             </a:r>
-            <a:endParaRPr lang="en-US" dirty="0"/>
           </a:p>
         </p:txBody>
       </p:sp>
@@ -863,7 +641,6 @@
               <a:rPr lang="en-US" dirty="0"/>
               <a:t>1:30. Closed-app, every morning, a scheduler runs this planner: grounded in today's facts it PROPOSES — a gift for the birthday it sees, the next step of a goal it's tracking — and deterministic code stages the proposals as confirm-tier drafts. Model proposes, code stages, parent approves.</a:t>
             </a:r>
-            <a:endParaRPr lang="en-US" dirty="0"/>
           </a:p>
         </p:txBody>
       </p:sp>
@@ -951,7 +728,6 @@
               <a:rPr lang="en-US" dirty="0"/>
               <a:t>1:45. The wall tablet is the kid surface. One toggle: picture-first chores for a four-year-old, confetti on completion — and every destructive tap is gone. The ask-box stays, because the worst a kid's request can do is stage a draft for a parent.</a:t>
             </a:r>
-            <a:endParaRPr lang="en-US" dirty="0"/>
           </a:p>
         </p:txBody>
       </p:sp>
@@ -1039,7 +815,6 @@
               <a:rPr lang="en-US" dirty="0"/>
               <a:t>1:55. Built solo, vibe-coded end to end. It started life as a Google AI Studio app; Antigravity ran an early dev pass — and here it is later reviewing the shipped dark-mode shell for UX and accessibility [SHOW THE JUN 24 ANTIGRAVITY SESSION]. The main loop ran in Claude Code with Gemini as the runtime brain the whole way. The eval suite does something rare for agent demos: it attacks the agent — and pins the safety invariants as tests.</a:t>
             </a:r>
-            <a:endParaRPr lang="en-US" dirty="0"/>
           </a:p>
         </p:txBody>
       </p:sp>
@@ -1127,7 +902,6 @@
               <a:rPr lang="en-US" dirty="0"/>
               <a:t>2:10 to ~5:00 — LIVE DEMO, fresh incognito window, pre-warmed demo. Follow the six beats on this slide in order; they are the README Golden Path. Close over the Today page: "Family-Hub. A multi-agent concierge with the safety story first — and a four-year-old-safe front end. The link's below — ask it for your weekend."</a:t>
             </a:r>
-            <a:endParaRPr lang="en-US" dirty="0"/>
           </a:p>
         </p:txBody>
       </p:sp>
@@ -1158,6 +932,92 @@
     <p:extLst>
       <p:ext uri="{BB962C8B-B14F-4D97-AF65-F5344CB8AC3E}">
         <p14:creationId xmlns:p14="http://schemas.microsoft.com/office/powerpoint/2010/main" val="1024086991"/>
+      </p:ext>
+    </p:extLst>
+  </p:cSld>
+  <p:clrMapOvr>
+    <a:masterClrMapping/>
+  </p:clrMapOvr>
+</p:notes>
+</file>
+
+<file path=ppt/notesSlides/notesSlide9.xml><?xml version="1.0" encoding="utf-8"?>
+<p:notes xmlns:a="http://schemas.openxmlformats.org/drawingml/2006/main" xmlns:r="http://schemas.openxmlformats.org/officeDocument/2006/relationships" xmlns:p="http://schemas.openxmlformats.org/presentationml/2006/main">
+  <p:cSld>
+    <p:spTree>
+      <p:nvGrpSpPr>
+        <p:cNvPr id="1" name=""/>
+        <p:cNvGrpSpPr/>
+        <p:nvPr/>
+      </p:nvGrpSpPr>
+      <p:grpSpPr>
+        <a:xfrm>
+          <a:off x="0" y="0"/>
+          <a:ext cx="0" cy="0"/>
+          <a:chOff x="0" y="0"/>
+          <a:chExt cx="0" cy="0"/>
+        </a:xfrm>
+      </p:grpSpPr>
+      <p:sp>
+        <p:nvSpPr>
+          <p:cNvPr id="2" name="Slide Image Placeholder 1"/>
+          <p:cNvSpPr>
+            <a:spLocks noGrp="1" noRot="1" noChangeAspect="1"/>
+          </p:cNvSpPr>
+          <p:nvPr>
+            <p:ph type="sldImg"/>
+          </p:nvPr>
+        </p:nvSpPr>
+        <p:spPr>
+          <a:xfrm>
+            <a:off x="-225425" y="1524000"/>
+            <a:ext cx="7308850" cy="4113213"/>
+          </a:xfrm>
+          <a:prstGeom prst="rect">
+            <a:avLst/>
+          </a:prstGeom>
+          <a:noFill/>
+          <a:ln w="12700">
+            <a:solidFill>
+              <a:prstClr val="black"/>
+            </a:solidFill>
+          </a:ln>
+        </p:spPr>
+      </p:sp>
+      <p:sp>
+        <p:nvSpPr>
+          <p:cNvPr id="3" name="Notes Placeholder 2"/>
+          <p:cNvSpPr>
+            <a:spLocks noGrp="1"/>
+          </p:cNvSpPr>
+          <p:nvPr>
+            <p:ph type="body" idx="1"/>
+          </p:nvPr>
+        </p:nvSpPr>
+        <p:spPr>
+          <a:xfrm>
+            <a:off x="685800" y="5865813"/>
+            <a:ext cx="5486400" cy="4799012"/>
+          </a:xfrm>
+          <a:prstGeom prst="rect">
+            <a:avLst/>
+          </a:prstGeom>
+        </p:spPr>
+        <p:txBody>
+          <a:bodyPr/>
+          <a:lstStyle/>
+          <a:p>
+            <a:r>
+              <a:rPr lang="en-US"/>
+              <a:t>4:50. What's next keeps the same safety spine: real Kroger carts - their API literally has no payment endpoint, so the invariant holds by contract; a fully local, zero-dollar private mode; and deeper proactivity - every new capability still lands behind the same approval gate. Family-Hub. Ask it for your weekend.</a:t>
+            </a:r>
+          </a:p>
+        </p:txBody>
+      </p:sp>
+    </p:spTree>
+    <p:extLst>
+      <p:ext uri="{BB962C8B-B14F-4D97-AF65-F5344CB8AC3E}">
+        <p14:creationId xmlns:p14="http://schemas.microsoft.com/office/powerpoint/2010/main" val="1506119558"/>
       </p:ext>
     </p:extLst>
   </p:cSld>
@@ -1200,6 +1060,11 @@
 <file path=ppt/slideMasters/slideMaster1.xml><?xml version="1.0" encoding="utf-8"?>
 <p:sldMaster xmlns:a="http://schemas.openxmlformats.org/drawingml/2006/main" xmlns:r="http://schemas.openxmlformats.org/officeDocument/2006/relationships" xmlns:p="http://schemas.openxmlformats.org/presentationml/2006/main">
   <p:cSld>
+    <p:bg>
+      <p:bgRef idx="1001">
+        <a:schemeClr val="bg1"/>
+      </p:bgRef>
+    </p:bg>
     <p:spTree>
       <p:nvGrpSpPr>
         <p:cNvPr id="1" name=""/>
@@ -1482,6 +1347,7 @@
         <a:solidFill>
           <a:srgbClr val="0B0F1A"/>
         </a:solidFill>
+        <a:effectLst/>
       </p:bgPr>
     </p:bg>
     <p:spTree>
@@ -1500,15 +1366,15 @@
       </p:grpSpPr>
       <p:pic>
         <p:nvPicPr>
-          <p:cNvPr id="2" name="Image 0" descr="docs/kaggle-cover.png">    </p:cNvPr>
+          <p:cNvPr id="2" name="Image 0" descr="docs/kaggle-cover.png"/>
           <p:cNvPicPr>
             <a:picLocks noChangeAspect="1"/>
           </p:cNvPicPr>
           <p:nvPr/>
         </p:nvPicPr>
         <p:blipFill>
-          <a:blip r:embed="rId1"/>
-          <a:srcRect l="0" r="0" t="0" b="0"/>
+          <a:blip r:embed="rId3"/>
+          <a:srcRect/>
           <a:stretch/>
         </p:blipFill>
         <p:spPr>
@@ -1564,7 +1430,7 @@
           <a:bodyPr wrap="square" rtlCol="0" anchor="ctr"/>
           <a:lstStyle/>
           <a:p>
-            <a:pPr indent="0" marL="0">
+            <a:pPr marL="0" indent="0">
               <a:buNone/>
             </a:pPr>
             <a:r>
@@ -1603,7 +1469,7 @@
           <a:bodyPr wrap="square" rtlCol="0" anchor="ctr"/>
           <a:lstStyle/>
           <a:p>
-            <a:pPr indent="0" marL="0">
+            <a:pPr marL="0" indent="0">
               <a:buNone/>
             </a:pPr>
             <a:r>
@@ -1615,7 +1481,7 @@
                 <a:ea typeface="Calibri" pitchFamily="34" charset="-122"/>
                 <a:cs typeface="Calibri" pitchFamily="34" charset="-120"/>
               </a:rPr>
-              <a:t>An agent that runs your family’s week.</a:t>
+              <a:t>An agent that helps plan then runs your family’s week.</a:t>
             </a:r>
             <a:endParaRPr lang="en-US" sz="2200" dirty="0"/>
           </a:p>
@@ -1642,35 +1508,9 @@
           <a:bodyPr wrap="square" rtlCol="0" anchor="ctr"/>
           <a:lstStyle/>
           <a:p>
-            <a:pPr indent="0" marL="0">
+            <a:pPr marL="0" indent="0">
               <a:buNone/>
             </a:pPr>
-            <a:r>
-              <a:rPr lang="en-US" sz="2600" dirty="0">
-                <a:solidFill>
-                  <a:srgbClr val="F4F5FF"/>
-                </a:solidFill>
-                <a:latin typeface="Arial" pitchFamily="34" charset="0"/>
-                <a:ea typeface="Arial" pitchFamily="34" charset="-122"/>
-                <a:cs typeface="Arial" pitchFamily="34" charset="-120"/>
-              </a:rPr>
-              <a:t>It can’t spend our money.
-</a:t>
-            </a:r>
-            <a:pPr indent="0" marL="0">
-              <a:buNone/>
-            </a:pPr>
-            <a:r>
-              <a:rPr lang="en-US" sz="2600" b="1" dirty="0">
-                <a:solidFill>
-                  <a:srgbClr val="F2B84B"/>
-                </a:solidFill>
-                <a:latin typeface="Arial" pitchFamily="34" charset="0"/>
-                <a:ea typeface="Arial" pitchFamily="34" charset="-122"/>
-                <a:cs typeface="Arial" pitchFamily="34" charset="-120"/>
-              </a:rPr>
-              <a:t>Not won’t — can’t.</a:t>
-            </a:r>
             <a:endParaRPr lang="en-US" sz="2600" dirty="0"/>
           </a:p>
         </p:txBody>
@@ -1696,7 +1536,7 @@
           <a:bodyPr wrap="square" rtlCol="0" anchor="ctr"/>
           <a:lstStyle/>
           <a:p>
-            <a:pPr indent="0" marL="0">
+            <a:pPr marL="0" indent="0">
               <a:buNone/>
             </a:pPr>
             <a:r>
@@ -1730,6 +1570,7 @@
         <a:solidFill>
           <a:srgbClr val="0B0F1A"/>
         </a:solidFill>
+        <a:effectLst/>
       </p:bgPr>
     </p:bg>
     <p:spTree>
@@ -1767,11 +1608,11 @@
           <a:bodyPr wrap="square" rtlCol="0" anchor="ctr"/>
           <a:lstStyle/>
           <a:p>
-            <a:pPr indent="0" marL="0">
+            <a:pPr marL="0" indent="0">
               <a:buNone/>
             </a:pPr>
             <a:r>
-              <a:rPr lang="en-US" sz="1200" b="1" spc="300" kern="0" dirty="0">
+              <a:rPr lang="en-US" sz="1200" b="1" kern="0" spc="300" dirty="0">
                 <a:solidFill>
                   <a:srgbClr val="7C7FF2"/>
                 </a:solidFill>
@@ -1806,7 +1647,7 @@
           <a:bodyPr wrap="square" rtlCol="0" anchor="ctr"/>
           <a:lstStyle/>
           <a:p>
-            <a:pPr indent="0" marL="0">
+            <a:pPr marL="0" indent="0">
               <a:buNone/>
             </a:pPr>
             <a:r>
@@ -1826,14 +1667,14 @@
       </p:sp>
       <p:pic>
         <p:nvPicPr>
-          <p:cNvPr id="4" name="Image 0" descr="docs/user-guide/02-today.png">    </p:cNvPr>
+          <p:cNvPr id="4" name="Image 0" descr="docs/user-guide/02-today.png"/>
           <p:cNvPicPr>
             <a:picLocks noChangeAspect="1"/>
           </p:cNvPicPr>
           <p:nvPr/>
         </p:nvPicPr>
         <p:blipFill>
-          <a:blip r:embed="rId1"/>
+          <a:blip r:embed="rId3"/>
           <a:stretch>
             <a:fillRect/>
           </a:stretch>
@@ -1847,7 +1688,7 @@
             <a:avLst/>
           </a:prstGeom>
           <a:effectLst>
-            <a:outerShdw sx="100000" sy="100000" kx="0" ky="0" algn="bl" rotWithShape="0" blurRad="177800" dist="63500" dir="5400000">
+            <a:outerShdw blurRad="177800" dist="63500" dir="5400000" algn="bl" rotWithShape="0">
               <a:srgbClr val="000000">
                 <a:alpha val="55000"/>
               </a:srgbClr>
@@ -1892,7 +1733,7 @@
                 <a:ea typeface="Calibri" pitchFamily="34" charset="-122"/>
                 <a:cs typeface="Calibri" pitchFamily="34" charset="-120"/>
               </a:rPr>
-              <a:t>Research the park’s pass rules on the live web</a:t>
+              <a:t>Research a national park’s pass rules on the live web for an outing</a:t>
             </a:r>
             <a:endParaRPr lang="en-US" sz="1700" dirty="0"/>
           </a:p>
@@ -1982,7 +1823,7 @@
           <a:bodyPr wrap="square" rtlCol="0" anchor="ctr"/>
           <a:lstStyle/>
           <a:p>
-            <a:pPr indent="0" marL="0">
+            <a:pPr marL="0" indent="0">
               <a:buNone/>
             </a:pPr>
             <a:r>
@@ -2016,6 +1857,7 @@
         <a:solidFill>
           <a:srgbClr val="0B0F1A"/>
         </a:solidFill>
+        <a:effectLst/>
       </p:bgPr>
     </p:bg>
     <p:spTree>
@@ -2053,11 +1895,11 @@
           <a:bodyPr wrap="square" rtlCol="0" anchor="ctr"/>
           <a:lstStyle/>
           <a:p>
-            <a:pPr indent="0" marL="0">
+            <a:pPr marL="0" indent="0">
               <a:buNone/>
             </a:pPr>
             <a:r>
-              <a:rPr lang="en-US" sz="1200" b="1" spc="300" kern="0" dirty="0">
+              <a:rPr lang="en-US" sz="1200" b="1" kern="0" spc="300" dirty="0">
                 <a:solidFill>
                   <a:srgbClr val="7C7FF2"/>
                 </a:solidFill>
@@ -2092,7 +1934,7 @@
           <a:bodyPr wrap="square" rtlCol="0" anchor="ctr"/>
           <a:lstStyle/>
           <a:p>
-            <a:pPr indent="0" marL="0">
+            <a:pPr marL="0" indent="0">
               <a:buNone/>
             </a:pPr>
             <a:r>
@@ -2158,7 +2000,7 @@
           <a:bodyPr wrap="square" rtlCol="0" anchor="ctr"/>
           <a:lstStyle/>
           <a:p>
-            <a:pPr algn="ctr" indent="0" marL="0">
+            <a:pPr marL="0" indent="0" algn="ctr">
               <a:buNone/>
             </a:pPr>
             <a:r>
@@ -2224,7 +2066,7 @@
           <a:bodyPr wrap="square" rtlCol="0" anchor="ctr"/>
           <a:lstStyle/>
           <a:p>
-            <a:pPr algn="ctr" indent="0" marL="0">
+            <a:pPr marL="0" indent="0" algn="ctr">
               <a:buNone/>
             </a:pPr>
             <a:r>
@@ -2241,7 +2083,7 @@
             <a:endParaRPr lang="en-US" sz="1400" dirty="0"/>
           </a:p>
           <a:p>
-            <a:pPr algn="ctr" indent="0" marL="0">
+            <a:pPr marL="0" indent="0" algn="ctr">
               <a:buNone/>
             </a:pPr>
             <a:r>
@@ -2258,7 +2100,7 @@
             <a:endParaRPr lang="en-US" sz="1400" dirty="0"/>
           </a:p>
           <a:p>
-            <a:pPr algn="ctr" indent="0" marL="0">
+            <a:pPr marL="0" indent="0" algn="ctr">
               <a:buNone/>
             </a:pPr>
             <a:r>
@@ -2324,7 +2166,7 @@
           <a:bodyPr wrap="square" rtlCol="0" anchor="ctr"/>
           <a:lstStyle/>
           <a:p>
-            <a:pPr algn="ctr" indent="0" marL="0">
+            <a:pPr marL="0" indent="0" algn="ctr">
               <a:buNone/>
             </a:pPr>
             <a:r>
@@ -2341,7 +2183,7 @@
             <a:endParaRPr lang="en-US" sz="1400" dirty="0"/>
           </a:p>
           <a:p>
-            <a:pPr algn="ctr" indent="0" marL="0">
+            <a:pPr marL="0" indent="0" algn="ctr">
               <a:buNone/>
             </a:pPr>
             <a:r>
@@ -2358,7 +2200,7 @@
             <a:endParaRPr lang="en-US" sz="1400" dirty="0"/>
           </a:p>
           <a:p>
-            <a:pPr algn="ctr" indent="0" marL="0">
+            <a:pPr marL="0" indent="0" algn="ctr">
               <a:buNone/>
             </a:pPr>
             <a:r>
@@ -2424,7 +2266,7 @@
           <a:bodyPr wrap="square" rtlCol="0" anchor="ctr"/>
           <a:lstStyle/>
           <a:p>
-            <a:pPr algn="ctr" indent="0" marL="0">
+            <a:pPr marL="0" indent="0" algn="ctr">
               <a:buNone/>
             </a:pPr>
             <a:r>
@@ -2441,7 +2283,7 @@
             <a:endParaRPr lang="en-US" sz="1300" dirty="0"/>
           </a:p>
           <a:p>
-            <a:pPr algn="ctr" indent="0" marL="0">
+            <a:pPr marL="0" indent="0" algn="ctr">
               <a:buNone/>
             </a:pPr>
             <a:r>
@@ -2458,7 +2300,7 @@
             <a:endParaRPr lang="en-US" sz="1300" dirty="0"/>
           </a:p>
           <a:p>
-            <a:pPr algn="ctr" indent="0" marL="0">
+            <a:pPr marL="0" indent="0" algn="ctr">
               <a:buNone/>
             </a:pPr>
             <a:r>
@@ -2524,7 +2366,7 @@
           <a:bodyPr wrap="square" rtlCol="0" anchor="ctr"/>
           <a:lstStyle/>
           <a:p>
-            <a:pPr algn="ctr" indent="0" marL="0">
+            <a:pPr marL="0" indent="0" algn="ctr">
               <a:buNone/>
             </a:pPr>
             <a:r>
@@ -2541,7 +2383,7 @@
             <a:endParaRPr lang="en-US" sz="1300" dirty="0"/>
           </a:p>
           <a:p>
-            <a:pPr algn="ctr" indent="0" marL="0">
+            <a:pPr marL="0" indent="0" algn="ctr">
               <a:buNone/>
             </a:pPr>
             <a:r>
@@ -2558,7 +2400,7 @@
             <a:endParaRPr lang="en-US" sz="1300" dirty="0"/>
           </a:p>
           <a:p>
-            <a:pPr algn="ctr" indent="0" marL="0">
+            <a:pPr marL="0" indent="0" algn="ctr">
               <a:buNone/>
             </a:pPr>
             <a:r>
@@ -2597,7 +2439,7 @@
           <a:bodyPr wrap="square" rtlCol="0" anchor="ctr"/>
           <a:lstStyle/>
           <a:p>
-            <a:pPr algn="ctr" indent="0" marL="0">
+            <a:pPr marL="0" indent="0" algn="ctr">
               <a:buNone/>
             </a:pPr>
             <a:r>
@@ -2633,7 +2475,7 @@
           <a:bodyPr wrap="square" rtlCol="0" anchor="ctr"/>
           <a:lstStyle/>
           <a:p>
-            <a:pPr algn="ctr" indent="0" marL="0">
+            <a:pPr marL="0" indent="0" algn="ctr">
               <a:buNone/>
             </a:pPr>
             <a:r>
@@ -2669,7 +2511,7 @@
           <a:bodyPr wrap="square" rtlCol="0" anchor="ctr"/>
           <a:lstStyle/>
           <a:p>
-            <a:pPr algn="ctr" indent="0" marL="0">
+            <a:pPr marL="0" indent="0" algn="ctr">
               <a:buNone/>
             </a:pPr>
             <a:r>
@@ -2705,7 +2547,7 @@
           <a:bodyPr wrap="square" rtlCol="0" anchor="ctr"/>
           <a:lstStyle/>
           <a:p>
-            <a:pPr algn="ctr" indent="0" marL="0">
+            <a:pPr marL="0" indent="0" algn="ctr">
               <a:buNone/>
             </a:pPr>
             <a:r>
@@ -2757,7 +2599,7 @@
                 <a:ea typeface="Calibri" pitchFamily="34" charset="-122"/>
                 <a:cs typeface="Calibri" pitchFamily="34" charset="-120"/>
               </a:rPr>
-              <a:t>Simple asks: the model reasons over pre-verified facts — it can’t invent a venue</a:t>
+              <a:t>Simple asks: the model reasons over pre-verified facts — for instance, it can’t invent a venue</a:t>
             </a:r>
             <a:endParaRPr lang="en-US" sz="1400" dirty="0"/>
           </a:p>
@@ -2778,7 +2620,7 @@
                 <a:ea typeface="Calibri" pitchFamily="34" charset="-122"/>
                 <a:cs typeface="Calibri" pitchFamily="34" charset="-120"/>
               </a:rPr>
-              <a:t>Action turns: root delegates; the shopping agent literally cannot touch the calendar</a:t>
+              <a:t>Action turns: root delegates; separation maintains between the specialists; e.g. the shopping agent literally cannot touch the calendar</a:t>
             </a:r>
             <a:endParaRPr lang="en-US" sz="1400" dirty="0"/>
           </a:p>
@@ -2821,6 +2663,7 @@
         <a:solidFill>
           <a:srgbClr val="0B0F1A"/>
         </a:solidFill>
+        <a:effectLst/>
       </p:bgPr>
     </p:bg>
     <p:spTree>
@@ -2858,11 +2701,11 @@
           <a:bodyPr wrap="square" rtlCol="0" anchor="ctr"/>
           <a:lstStyle/>
           <a:p>
-            <a:pPr indent="0" marL="0">
+            <a:pPr marL="0" indent="0">
               <a:buNone/>
             </a:pPr>
             <a:r>
-              <a:rPr lang="en-US" sz="1200" b="1" spc="300" kern="0" dirty="0">
+              <a:rPr lang="en-US" sz="1200" b="1" kern="0" spc="300" dirty="0">
                 <a:solidFill>
                   <a:srgbClr val="7C7FF2"/>
                 </a:solidFill>
@@ -2897,7 +2740,7 @@
           <a:bodyPr wrap="square" rtlCol="0" anchor="ctr"/>
           <a:lstStyle/>
           <a:p>
-            <a:pPr indent="0" marL="0">
+            <a:pPr marL="0" indent="0">
               <a:buNone/>
             </a:pPr>
             <a:r>
@@ -2909,7 +2752,7 @@
                 <a:ea typeface="Arial" pitchFamily="34" charset="-122"/>
                 <a:cs typeface="Arial" pitchFamily="34" charset="-120"/>
               </a:rPr>
-              <a:t>The parent stays the approver</a:t>
+              <a:t>The adult stays the approver</a:t>
             </a:r>
             <a:endParaRPr lang="en-US" sz="3400" dirty="0"/>
           </a:p>
@@ -2917,14 +2760,14 @@
       </p:sp>
       <p:pic>
         <p:nvPicPr>
-          <p:cNvPr id="4" name="Image 0" descr="docs/user-guide/11-approvals.png">    </p:cNvPr>
+          <p:cNvPr id="4" name="Image 0" descr="docs/user-guide/11-approvals.png"/>
           <p:cNvPicPr>
             <a:picLocks noChangeAspect="1"/>
           </p:cNvPicPr>
           <p:nvPr/>
         </p:nvPicPr>
         <p:blipFill>
-          <a:blip r:embed="rId1"/>
+          <a:blip r:embed="rId3"/>
           <a:stretch>
             <a:fillRect/>
           </a:stretch>
@@ -2938,7 +2781,7 @@
             <a:avLst/>
           </a:prstGeom>
           <a:effectLst>
-            <a:outerShdw sx="100000" sy="100000" kx="0" ky="0" algn="bl" rotWithShape="0" blurRad="177800" dist="63500" dir="5400000">
+            <a:outerShdw blurRad="177800" dist="63500" dir="5400000" algn="bl" rotWithShape="0">
               <a:srgbClr val="000000">
                 <a:alpha val="55000"/>
               </a:srgbClr>
@@ -3110,6 +2953,7 @@
         <a:solidFill>
           <a:srgbClr val="0B0F1A"/>
         </a:solidFill>
+        <a:effectLst/>
       </p:bgPr>
     </p:bg>
     <p:spTree>
@@ -3147,11 +2991,11 @@
           <a:bodyPr wrap="square" rtlCol="0" anchor="ctr"/>
           <a:lstStyle/>
           <a:p>
-            <a:pPr indent="0" marL="0">
+            <a:pPr marL="0" indent="0">
               <a:buNone/>
             </a:pPr>
             <a:r>
-              <a:rPr lang="en-US" sz="1200" b="1" spc="300" kern="0" dirty="0">
+              <a:rPr lang="en-US" sz="1200" b="1" kern="0" spc="300" dirty="0">
                 <a:solidFill>
                   <a:srgbClr val="7C7FF2"/>
                 </a:solidFill>
@@ -3186,7 +3030,7 @@
           <a:bodyPr wrap="square" rtlCol="0" anchor="ctr"/>
           <a:lstStyle/>
           <a:p>
-            <a:pPr indent="0" marL="0">
+            <a:pPr marL="0" indent="0">
               <a:buNone/>
             </a:pPr>
             <a:r>
@@ -3206,14 +3050,14 @@
       </p:sp>
       <p:pic>
         <p:nvPicPr>
-          <p:cNvPr id="4" name="Image 0" descr="docs/user-guide/04-briefing.png">    </p:cNvPr>
+          <p:cNvPr id="4" name="Image 0" descr="docs/user-guide/04-briefing.png"/>
           <p:cNvPicPr>
             <a:picLocks noChangeAspect="1"/>
           </p:cNvPicPr>
           <p:nvPr/>
         </p:nvPicPr>
         <p:blipFill>
-          <a:blip r:embed="rId1"/>
+          <a:blip r:embed="rId3"/>
           <a:stretch>
             <a:fillRect/>
           </a:stretch>
@@ -3227,7 +3071,7 @@
             <a:avLst/>
           </a:prstGeom>
           <a:effectLst>
-            <a:outerShdw sx="100000" sy="100000" kx="0" ky="0" algn="bl" rotWithShape="0" blurRad="177800" dist="63500" dir="5400000">
+            <a:outerShdw blurRad="177800" dist="63500" dir="5400000" algn="bl" rotWithShape="0">
               <a:srgbClr val="000000">
                 <a:alpha val="55000"/>
               </a:srgbClr>
@@ -3256,7 +3100,7 @@
           <a:bodyPr wrap="square" rtlCol="0" anchor="t"/>
           <a:lstStyle/>
           <a:p>
-            <a:pPr indent="0" marL="0">
+            <a:pPr marL="0" indent="0">
               <a:buNone/>
             </a:pPr>
             <a:r>
@@ -3270,9 +3114,6 @@
               </a:rPr>
               <a:t>Model proposes. </a:t>
             </a:r>
-            <a:pPr indent="0" marL="0">
-              <a:buNone/>
-            </a:pPr>
             <a:r>
               <a:rPr lang="en-US" sz="1700" dirty="0">
                 <a:solidFill>
@@ -3285,9 +3126,6 @@
               <a:t>Reads today’s facts, proposes up to 3 concrete actions.
 </a:t>
             </a:r>
-            <a:pPr indent="0" marL="0">
-              <a:buNone/>
-            </a:pPr>
             <a:r>
               <a:rPr lang="en-US" sz="1700" b="1" dirty="0">
                 <a:solidFill>
@@ -3299,9 +3137,6 @@
               </a:rPr>
               <a:t>Code stages. </a:t>
             </a:r>
-            <a:pPr indent="0" marL="0">
-              <a:buNone/>
-            </a:pPr>
             <a:r>
               <a:rPr lang="en-US" sz="1700" dirty="0">
                 <a:solidFill>
@@ -3314,9 +3149,6 @@
               <a:t>Deterministic validation; every draft is confirm-tier.
 </a:t>
             </a:r>
-            <a:pPr indent="0" marL="0">
-              <a:buNone/>
-            </a:pPr>
             <a:r>
               <a:rPr lang="en-US" sz="1700" b="1" dirty="0">
                 <a:solidFill>
@@ -3326,11 +3158,8 @@
                 <a:ea typeface="Calibri" pitchFamily="34" charset="-122"/>
                 <a:cs typeface="Calibri" pitchFamily="34" charset="-120"/>
               </a:rPr>
-              <a:t>Parent approves. </a:t>
-            </a:r>
-            <a:pPr indent="0" marL="0">
-              <a:buNone/>
-            </a:pPr>
+              <a:t>Parent/Adult approves. </a:t>
+            </a:r>
             <a:r>
               <a:rPr lang="en-US" sz="1700" dirty="0">
                 <a:solidFill>
@@ -3362,6 +3191,7 @@
         <a:solidFill>
           <a:srgbClr val="0B0F1A"/>
         </a:solidFill>
+        <a:effectLst/>
       </p:bgPr>
     </p:bg>
     <p:spTree>
@@ -3399,11 +3229,11 @@
           <a:bodyPr wrap="square" rtlCol="0" anchor="ctr"/>
           <a:lstStyle/>
           <a:p>
-            <a:pPr indent="0" marL="0">
+            <a:pPr marL="0" indent="0">
               <a:buNone/>
             </a:pPr>
             <a:r>
-              <a:rPr lang="en-US" sz="1200" b="1" spc="300" kern="0" dirty="0">
+              <a:rPr lang="en-US" sz="1200" b="1" kern="0" spc="300" dirty="0">
                 <a:solidFill>
                   <a:srgbClr val="7C7FF2"/>
                 </a:solidFill>
@@ -3411,7 +3241,7 @@
                 <a:ea typeface="Arial" pitchFamily="34" charset="-122"/>
                 <a:cs typeface="Arial" pitchFamily="34" charset="-120"/>
               </a:rPr>
-              <a:t>SAFE FOR AGE 4</a:t>
+              <a:t>SAFE FOR EVEN AGE 4</a:t>
             </a:r>
             <a:endParaRPr lang="en-US" sz="1200" dirty="0"/>
           </a:p>
@@ -3438,7 +3268,7 @@
           <a:bodyPr wrap="square" rtlCol="0" anchor="ctr"/>
           <a:lstStyle/>
           <a:p>
-            <a:pPr indent="0" marL="0">
+            <a:pPr marL="0" indent="0">
               <a:buNone/>
             </a:pPr>
             <a:r>
@@ -3458,14 +3288,14 @@
       </p:sp>
       <p:pic>
         <p:nvPicPr>
-          <p:cNvPr id="4" name="Image 0" descr="docs/user-guide/14-kidmode-confetti.png">    </p:cNvPr>
+          <p:cNvPr id="4" name="Image 0" descr="docs/user-guide/14-kidmode-confetti.png"/>
           <p:cNvPicPr>
             <a:picLocks noChangeAspect="1"/>
           </p:cNvPicPr>
           <p:nvPr/>
         </p:nvPicPr>
         <p:blipFill>
-          <a:blip r:embed="rId1"/>
+          <a:blip r:embed="rId3"/>
           <a:stretch>
             <a:fillRect/>
           </a:stretch>
@@ -3479,7 +3309,7 @@
             <a:avLst/>
           </a:prstGeom>
           <a:effectLst>
-            <a:outerShdw sx="100000" sy="100000" kx="0" ky="0" algn="bl" rotWithShape="0" blurRad="177800" dist="63500" dir="5400000">
+            <a:outerShdw blurRad="177800" dist="63500" dir="5400000" algn="bl" rotWithShape="0">
               <a:srgbClr val="000000">
                 <a:alpha val="55000"/>
               </a:srgbClr>
@@ -3630,6 +3460,7 @@
         <a:solidFill>
           <a:srgbClr val="0B0F1A"/>
         </a:solidFill>
+        <a:effectLst/>
       </p:bgPr>
     </p:bg>
     <p:spTree>
@@ -3667,11 +3498,11 @@
           <a:bodyPr wrap="square" rtlCol="0" anchor="ctr"/>
           <a:lstStyle/>
           <a:p>
-            <a:pPr indent="0" marL="0">
+            <a:pPr marL="0" indent="0">
               <a:buNone/>
             </a:pPr>
             <a:r>
-              <a:rPr lang="en-US" sz="1200" b="1" spc="300" kern="0" dirty="0">
+              <a:rPr lang="en-US" sz="1200" b="1" kern="0" spc="300" dirty="0">
                 <a:solidFill>
                   <a:srgbClr val="7C7FF2"/>
                 </a:solidFill>
@@ -3706,7 +3537,7 @@
           <a:bodyPr wrap="square" rtlCol="0" anchor="ctr"/>
           <a:lstStyle/>
           <a:p>
-            <a:pPr indent="0" marL="0">
+            <a:pPr marL="0" indent="0">
               <a:buNone/>
             </a:pPr>
             <a:r>
@@ -3767,7 +3598,7 @@
           <a:bodyPr wrap="square" rtlCol="0" anchor="ctr"/>
           <a:lstStyle/>
           <a:p>
-            <a:pPr algn="ctr" indent="0" marL="0">
+            <a:pPr marL="0" indent="0" algn="ctr">
               <a:buNone/>
             </a:pPr>
             <a:r>
@@ -3806,7 +3637,7 @@
           <a:bodyPr wrap="square" rtlCol="0" anchor="ctr"/>
           <a:lstStyle/>
           <a:p>
-            <a:pPr algn="ctr" indent="0" marL="0">
+            <a:pPr marL="0" indent="0" algn="ctr">
               <a:buNone/>
             </a:pPr>
             <a:r>
@@ -3867,7 +3698,7 @@
           <a:bodyPr wrap="square" rtlCol="0" anchor="ctr"/>
           <a:lstStyle/>
           <a:p>
-            <a:pPr algn="ctr" indent="0" marL="0">
+            <a:pPr marL="0" indent="0" algn="ctr">
               <a:buNone/>
             </a:pPr>
             <a:r>
@@ -3906,7 +3737,7 @@
           <a:bodyPr wrap="square" rtlCol="0" anchor="ctr"/>
           <a:lstStyle/>
           <a:p>
-            <a:pPr algn="ctr" indent="0" marL="0">
+            <a:pPr marL="0" indent="0" algn="ctr">
               <a:buNone/>
             </a:pPr>
             <a:r>
@@ -3918,7 +3749,29 @@
                 <a:ea typeface="Calibri" pitchFamily="34" charset="-122"/>
                 <a:cs typeface="Calibri" pitchFamily="34" charset="-120"/>
               </a:rPr>
-              <a:t>early dev pass · later a full UX / accessibility review of the shipped shell</a:t>
+              <a:t>early dev pass · </a:t>
+            </a:r>
+            <a:r>
+              <a:rPr lang="en-US" sz="1250">
+                <a:solidFill>
+                  <a:srgbClr val="9AA1C0"/>
+                </a:solidFill>
+                <a:latin typeface="Calibri" pitchFamily="34" charset="0"/>
+                <a:ea typeface="Calibri" pitchFamily="34" charset="-122"/>
+                <a:cs typeface="Calibri" pitchFamily="34" charset="-120"/>
+              </a:rPr>
+              <a:t>later planning, architecture, </a:t>
+            </a:r>
+            <a:r>
+              <a:rPr lang="en-US" sz="1250" dirty="0">
+                <a:solidFill>
+                  <a:srgbClr val="9AA1C0"/>
+                </a:solidFill>
+                <a:latin typeface="Calibri" pitchFamily="34" charset="0"/>
+                <a:ea typeface="Calibri" pitchFamily="34" charset="-122"/>
+                <a:cs typeface="Calibri" pitchFamily="34" charset="-120"/>
+              </a:rPr>
+              <a:t>and code review partner · multiple full UX / accessibility reviews of the shipped shell throughout planning and development</a:t>
             </a:r>
             <a:endParaRPr lang="en-US" sz="1250" dirty="0"/>
           </a:p>
@@ -3967,7 +3820,7 @@
           <a:bodyPr wrap="square" rtlCol="0" anchor="ctr"/>
           <a:lstStyle/>
           <a:p>
-            <a:pPr algn="ctr" indent="0" marL="0">
+            <a:pPr marL="0" indent="0" algn="ctr">
               <a:buNone/>
             </a:pPr>
             <a:r>
@@ -4006,7 +3859,7 @@
           <a:bodyPr wrap="square" rtlCol="0" anchor="ctr"/>
           <a:lstStyle/>
           <a:p>
-            <a:pPr algn="ctr" indent="0" marL="0">
+            <a:pPr marL="0" indent="0" algn="ctr">
               <a:buNone/>
             </a:pPr>
             <a:r>
@@ -4045,7 +3898,7 @@
           <a:bodyPr wrap="square" rtlCol="0" anchor="ctr"/>
           <a:lstStyle/>
           <a:p>
-            <a:pPr algn="ctr" indent="0" marL="0">
+            <a:pPr marL="0" indent="0" algn="ctr">
               <a:buNone/>
             </a:pPr>
             <a:r>
@@ -4084,7 +3937,7 @@
           <a:bodyPr wrap="square" rtlCol="0" anchor="ctr"/>
           <a:lstStyle/>
           <a:p>
-            <a:pPr algn="ctr" indent="0" marL="0">
+            <a:pPr marL="0" indent="0" algn="ctr">
               <a:buNone/>
             </a:pPr>
             <a:r>
@@ -4118,6 +3971,7 @@
         <a:solidFill>
           <a:srgbClr val="0B0F1A"/>
         </a:solidFill>
+        <a:effectLst/>
       </p:bgPr>
     </p:bg>
     <p:spTree>
@@ -4155,7 +4009,7 @@
           <a:bodyPr wrap="square" rtlCol="0" anchor="ctr"/>
           <a:lstStyle/>
           <a:p>
-            <a:pPr algn="ctr" indent="0" marL="0">
+            <a:pPr marL="0" indent="0" algn="ctr">
               <a:buNone/>
             </a:pPr>
             <a:r>
@@ -4194,7 +4048,7 @@
           <a:bodyPr wrap="square" rtlCol="0" anchor="ctr"/>
           <a:lstStyle/>
           <a:p>
-            <a:pPr algn="ctr" indent="0" marL="0">
+            <a:pPr marL="0" indent="0" algn="ctr">
               <a:buNone/>
             </a:pPr>
             <a:r>
@@ -4233,7 +4087,7 @@
           <a:bodyPr wrap="square" rtlCol="0" anchor="t"/>
           <a:lstStyle/>
           <a:p>
-            <a:pPr indent="0" marL="0">
+            <a:pPr marL="0" indent="0">
               <a:spcAft>
                 <a:spcPts val="900"/>
               </a:spcAft>
@@ -4253,7 +4107,7 @@
             <a:endParaRPr lang="en-US" sz="1650" dirty="0"/>
           </a:p>
           <a:p>
-            <a:pPr indent="0" marL="0">
+            <a:pPr marL="0" indent="0">
               <a:spcAft>
                 <a:spcPts val="900"/>
               </a:spcAft>
@@ -4273,7 +4127,7 @@
             <a:endParaRPr lang="en-US" sz="1650" dirty="0"/>
           </a:p>
           <a:p>
-            <a:pPr indent="0" marL="0">
+            <a:pPr marL="0" indent="0">
               <a:spcAft>
                 <a:spcPts val="900"/>
               </a:spcAft>
@@ -4293,7 +4147,7 @@
             <a:endParaRPr lang="en-US" sz="1650" dirty="0"/>
           </a:p>
           <a:p>
-            <a:pPr indent="0" marL="0">
+            <a:pPr marL="0" indent="0">
               <a:spcAft>
                 <a:spcPts val="900"/>
               </a:spcAft>
@@ -4313,7 +4167,7 @@
             <a:endParaRPr lang="en-US" sz="1650" dirty="0"/>
           </a:p>
           <a:p>
-            <a:pPr indent="0" marL="0">
+            <a:pPr marL="0" indent="0">
               <a:spcAft>
                 <a:spcPts val="900"/>
               </a:spcAft>
@@ -4333,11 +4187,11 @@
             <a:endParaRPr lang="en-US" sz="1650" dirty="0"/>
           </a:p>
           <a:p>
-            <a:pPr indent="0" marL="0">
+            <a:pPr marL="342900" indent="-342900">
               <a:spcAft>
                 <a:spcPts val="900"/>
               </a:spcAft>
-              <a:buNone/>
+              <a:buAutoNum type="circleNumDbPlain" startAt="6"/>
             </a:pPr>
             <a:r>
               <a:rPr lang="en-US" sz="1650" dirty="0">
@@ -4348,9 +4202,591 @@
                 <a:ea typeface="Calibri" pitchFamily="34" charset="-122"/>
                 <a:cs typeface="Calibri" pitchFamily="34" charset="-120"/>
               </a:rPr>
-              <a:t>⑥  Manage → Kid mode ON → tap a chore → confetti → hold 🔒 to exit</a:t>
-            </a:r>
-            <a:endParaRPr lang="en-US" sz="1650" dirty="0"/>
+              <a:t>Manage → Kid mode ON → tap a chore → confetti → hold 🔒 </a:t>
+            </a:r>
+            <a:r>
+              <a:rPr lang="en-US" sz="1650">
+                <a:solidFill>
+                  <a:srgbClr val="F4F5FF"/>
+                </a:solidFill>
+                <a:latin typeface="Calibri" pitchFamily="34" charset="0"/>
+                <a:ea typeface="Calibri" pitchFamily="34" charset="-122"/>
+                <a:cs typeface="Calibri" pitchFamily="34" charset="-120"/>
+              </a:rPr>
+              <a:t>to exit</a:t>
+            </a:r>
+            <a:endParaRPr lang="en-US" sz="1650" dirty="0">
+              <a:solidFill>
+                <a:srgbClr val="F4F5FF"/>
+              </a:solidFill>
+              <a:latin typeface="Calibri" pitchFamily="34" charset="0"/>
+              <a:ea typeface="Calibri" pitchFamily="34" charset="-122"/>
+              <a:cs typeface="Calibri" pitchFamily="34" charset="-120"/>
+            </a:endParaRPr>
+          </a:p>
+        </p:txBody>
+      </p:sp>
+    </p:spTree>
+  </p:cSld>
+  <p:clrMapOvr>
+    <a:masterClrMapping/>
+  </p:clrMapOvr>
+</p:sld>
+</file>
+
+<file path=ppt/slides/slide9.xml><?xml version="1.0" encoding="utf-8"?>
+<p:sld xmlns:a="http://schemas.openxmlformats.org/drawingml/2006/main" xmlns:r="http://schemas.openxmlformats.org/officeDocument/2006/relationships" xmlns:p="http://schemas.openxmlformats.org/presentationml/2006/main">
+  <p:cSld>
+    <p:bg>
+      <p:bgPr>
+        <a:solidFill>
+          <a:srgbClr val="0B0F1A"/>
+        </a:solidFill>
+        <a:effectLst/>
+      </p:bgPr>
+    </p:bg>
+    <p:spTree>
+      <p:nvGrpSpPr>
+        <p:cNvPr id="1" name=""/>
+        <p:cNvGrpSpPr/>
+        <p:nvPr/>
+      </p:nvGrpSpPr>
+      <p:grpSpPr>
+        <a:xfrm>
+          <a:off x="0" y="0"/>
+          <a:ext cx="0" cy="0"/>
+          <a:chOff x="0" y="0"/>
+          <a:chExt cx="0" cy="0"/>
+        </a:xfrm>
+      </p:grpSpPr>
+      <p:sp>
+        <p:nvSpPr>
+          <p:cNvPr id="2" name="TextBox 1"/>
+          <p:cNvSpPr txBox="1"/>
+          <p:nvPr/>
+        </p:nvSpPr>
+        <p:spPr>
+          <a:xfrm>
+            <a:off x="566928" y="109728"/>
+            <a:ext cx="9144000" cy="320040"/>
+          </a:xfrm>
+          <a:prstGeom prst="rect">
+            <a:avLst/>
+          </a:prstGeom>
+          <a:noFill/>
+        </p:spPr>
+        <p:txBody>
+          <a:bodyPr wrap="square">
+            <a:spAutoFit/>
+          </a:bodyPr>
+          <a:lstStyle/>
+          <a:p>
+            <a:pPr algn="l"/>
+            <a:r>
+              <a:rPr sz="1200" b="1">
+                <a:solidFill>
+                  <a:srgbClr val="7C7FF2"/>
+                </a:solidFill>
+                <a:latin typeface="Arial"/>
+              </a:rPr>
+              <a:t>WHAT’S NEXT</a:t>
+            </a:r>
+          </a:p>
+        </p:txBody>
+      </p:sp>
+      <p:sp>
+        <p:nvSpPr>
+          <p:cNvPr id="3" name="TextBox 2"/>
+          <p:cNvSpPr txBox="1"/>
+          <p:nvPr/>
+        </p:nvSpPr>
+        <p:spPr>
+          <a:xfrm>
+            <a:off x="548640" y="411480"/>
+            <a:ext cx="11064240" cy="777240"/>
+          </a:xfrm>
+          <a:prstGeom prst="rect">
+            <a:avLst/>
+          </a:prstGeom>
+          <a:noFill/>
+        </p:spPr>
+        <p:txBody>
+          <a:bodyPr wrap="square">
+            <a:spAutoFit/>
+          </a:bodyPr>
+          <a:lstStyle/>
+          <a:p>
+            <a:pPr algn="l"/>
+            <a:r>
+              <a:rPr sz="3400" b="1">
+                <a:solidFill>
+                  <a:srgbClr val="F4F5FF"/>
+                </a:solidFill>
+                <a:latin typeface="Arial"/>
+              </a:rPr>
+              <a:t>This week’s roadmap — same safety spine</a:t>
+            </a:r>
+          </a:p>
+        </p:txBody>
+      </p:sp>
+      <p:sp>
+        <p:nvSpPr>
+          <p:cNvPr id="4" name="Rounded Rectangle 3"/>
+          <p:cNvSpPr/>
+          <p:nvPr/>
+        </p:nvSpPr>
+        <p:spPr>
+          <a:xfrm>
+            <a:off x="566928" y="1554480"/>
+            <a:ext cx="5440680" cy="1325880"/>
+          </a:xfrm>
+          <a:prstGeom prst="roundRect">
+            <a:avLst/>
+          </a:prstGeom>
+          <a:solidFill>
+            <a:srgbClr val="141A2E"/>
+          </a:solidFill>
+          <a:ln w="6350">
+            <a:solidFill>
+              <a:srgbClr val="7C7FF2"/>
+            </a:solidFill>
+          </a:ln>
+          <a:effectLst/>
+        </p:spPr>
+        <p:style>
+          <a:lnRef idx="1">
+            <a:schemeClr val="accent1"/>
+          </a:lnRef>
+          <a:fillRef idx="3">
+            <a:schemeClr val="accent1"/>
+          </a:fillRef>
+          <a:effectRef idx="2">
+            <a:schemeClr val="accent1"/>
+          </a:effectRef>
+          <a:fontRef idx="minor">
+            <a:schemeClr val="lt1"/>
+          </a:fontRef>
+        </p:style>
+        <p:txBody>
+          <a:bodyPr wrap="square" lIns="201168" tIns="128016" rIns="201168" rtlCol="0" anchor="ctr"/>
+          <a:lstStyle/>
+          <a:p>
+            <a:pPr algn="ctr"/>
+            <a:r>
+              <a:rPr sz="1550" b="1">
+                <a:solidFill>
+                  <a:srgbClr val="F2B84B"/>
+                </a:solidFill>
+                <a:latin typeface="Arial"/>
+              </a:rPr>
+              <a:t>Kroger cart integration</a:t>
+            </a:r>
+          </a:p>
+          <a:p>
+            <a:pPr>
+              <a:spcBef>
+                <a:spcPts val="300"/>
+              </a:spcBef>
+            </a:pPr>
+            <a:r>
+              <a:rPr sz="1250">
+                <a:solidFill>
+                  <a:srgbClr val="F4F5FF"/>
+                </a:solidFill>
+                <a:latin typeface="Calibri"/>
+              </a:rPr>
+              <a:t>“paneer butter masala” → one approved draft fills the QFC cart. Kroger’s API has no payment endpoint — the invariant holds by contract.</a:t>
+            </a:r>
+          </a:p>
+        </p:txBody>
+      </p:sp>
+      <p:sp>
+        <p:nvSpPr>
+          <p:cNvPr id="5" name="Rounded Rectangle 4"/>
+          <p:cNvSpPr/>
+          <p:nvPr/>
+        </p:nvSpPr>
+        <p:spPr>
+          <a:xfrm>
+            <a:off x="6327648" y="1554480"/>
+            <a:ext cx="5440680" cy="1325880"/>
+          </a:xfrm>
+          <a:prstGeom prst="roundRect">
+            <a:avLst/>
+          </a:prstGeom>
+          <a:solidFill>
+            <a:srgbClr val="141A2E"/>
+          </a:solidFill>
+          <a:ln w="6350">
+            <a:solidFill>
+              <a:srgbClr val="7C7FF2"/>
+            </a:solidFill>
+          </a:ln>
+          <a:effectLst/>
+        </p:spPr>
+        <p:style>
+          <a:lnRef idx="1">
+            <a:schemeClr val="accent1"/>
+          </a:lnRef>
+          <a:fillRef idx="3">
+            <a:schemeClr val="accent1"/>
+          </a:fillRef>
+          <a:effectRef idx="2">
+            <a:schemeClr val="accent1"/>
+          </a:effectRef>
+          <a:fontRef idx="minor">
+            <a:schemeClr val="lt1"/>
+          </a:fontRef>
+        </p:style>
+        <p:txBody>
+          <a:bodyPr wrap="square" lIns="201168" tIns="128016" rIns="201168" rtlCol="0" anchor="ctr"/>
+          <a:lstStyle/>
+          <a:p>
+            <a:pPr algn="ctr"/>
+            <a:r>
+              <a:rPr sz="1550" b="1">
+                <a:solidFill>
+                  <a:srgbClr val="F2B84B"/>
+                </a:solidFill>
+                <a:latin typeface="Arial"/>
+              </a:rPr>
+              <a:t>$0 private mode</a:t>
+            </a:r>
+          </a:p>
+          <a:p>
+            <a:pPr>
+              <a:spcBef>
+                <a:spcPts val="300"/>
+              </a:spcBef>
+            </a:pPr>
+            <a:r>
+              <a:rPr sz="1250">
+                <a:solidFill>
+                  <a:srgbClr val="F4F5FF"/>
+                </a:solidFill>
+                <a:latin typeface="Calibri"/>
+              </a:rPr>
+              <a:t>gpt-oss:20b running locally on the home box — no cloud, no bill. Eval-gated before it ever serves the family.</a:t>
+            </a:r>
+          </a:p>
+        </p:txBody>
+      </p:sp>
+      <p:sp>
+        <p:nvSpPr>
+          <p:cNvPr id="6" name="Rounded Rectangle 5"/>
+          <p:cNvSpPr/>
+          <p:nvPr/>
+        </p:nvSpPr>
+        <p:spPr>
+          <a:xfrm>
+            <a:off x="566928" y="3136391"/>
+            <a:ext cx="5440680" cy="1325880"/>
+          </a:xfrm>
+          <a:prstGeom prst="roundRect">
+            <a:avLst/>
+          </a:prstGeom>
+          <a:solidFill>
+            <a:srgbClr val="141A2E"/>
+          </a:solidFill>
+          <a:ln w="6350">
+            <a:solidFill>
+              <a:srgbClr val="7C7FF2"/>
+            </a:solidFill>
+          </a:ln>
+          <a:effectLst/>
+        </p:spPr>
+        <p:style>
+          <a:lnRef idx="1">
+            <a:schemeClr val="accent1"/>
+          </a:lnRef>
+          <a:fillRef idx="3">
+            <a:schemeClr val="accent1"/>
+          </a:fillRef>
+          <a:effectRef idx="2">
+            <a:schemeClr val="accent1"/>
+          </a:effectRef>
+          <a:fontRef idx="minor">
+            <a:schemeClr val="lt1"/>
+          </a:fontRef>
+        </p:style>
+        <p:txBody>
+          <a:bodyPr wrap="square" lIns="201168" tIns="128016" rIns="201168" rtlCol="0" anchor="ctr"/>
+          <a:lstStyle/>
+          <a:p>
+            <a:pPr algn="ctr"/>
+            <a:r>
+              <a:rPr sz="1550" b="1">
+                <a:solidFill>
+                  <a:srgbClr val="7C7FF2"/>
+                </a:solidFill>
+                <a:latin typeface="Arial"/>
+              </a:rPr>
+              <a:t>Household-defined store lists</a:t>
+            </a:r>
+          </a:p>
+          <a:p>
+            <a:pPr>
+              <a:spcBef>
+                <a:spcPts val="300"/>
+              </a:spcBef>
+            </a:pPr>
+            <a:r>
+              <a:rPr sz="1250">
+                <a:solidFill>
+                  <a:srgbClr val="F4F5FF"/>
+                </a:solidFill>
+                <a:latin typeface="Calibri"/>
+              </a:rPr>
+              <a:t>Your stores, not ours — rename Costco, add the farmers market.</a:t>
+            </a:r>
+          </a:p>
+        </p:txBody>
+      </p:sp>
+      <p:sp>
+        <p:nvSpPr>
+          <p:cNvPr id="7" name="Rounded Rectangle 6"/>
+          <p:cNvSpPr/>
+          <p:nvPr/>
+        </p:nvSpPr>
+        <p:spPr>
+          <a:xfrm>
+            <a:off x="6327648" y="3136391"/>
+            <a:ext cx="5440680" cy="1325880"/>
+          </a:xfrm>
+          <a:prstGeom prst="roundRect">
+            <a:avLst/>
+          </a:prstGeom>
+          <a:solidFill>
+            <a:srgbClr val="141A2E"/>
+          </a:solidFill>
+          <a:ln w="6350">
+            <a:solidFill>
+              <a:srgbClr val="7C7FF2"/>
+            </a:solidFill>
+          </a:ln>
+          <a:effectLst/>
+        </p:spPr>
+        <p:style>
+          <a:lnRef idx="1">
+            <a:schemeClr val="accent1"/>
+          </a:lnRef>
+          <a:fillRef idx="3">
+            <a:schemeClr val="accent1"/>
+          </a:fillRef>
+          <a:effectRef idx="2">
+            <a:schemeClr val="accent1"/>
+          </a:effectRef>
+          <a:fontRef idx="minor">
+            <a:schemeClr val="lt1"/>
+          </a:fontRef>
+        </p:style>
+        <p:txBody>
+          <a:bodyPr wrap="square" lIns="201168" tIns="128016" rIns="201168" rtlCol="0" anchor="ctr"/>
+          <a:lstStyle/>
+          <a:p>
+            <a:pPr algn="ctr"/>
+            <a:r>
+              <a:rPr sz="1550" b="1">
+                <a:solidFill>
+                  <a:srgbClr val="7C7FF2"/>
+                </a:solidFill>
+                <a:latin typeface="Arial"/>
+              </a:rPr>
+              <a:t>Browser form-fill</a:t>
+            </a:r>
+          </a:p>
+          <a:p>
+            <a:pPr>
+              <a:spcBef>
+                <a:spcPts val="300"/>
+              </a:spcBef>
+            </a:pPr>
+            <a:r>
+              <a:rPr sz="1250">
+                <a:solidFill>
+                  <a:srgbClr val="F4F5FF"/>
+                </a:solidFill>
+                <a:latin typeface="Calibri"/>
+              </a:rPr>
+              <a:t>The last booking step, behind the step-up PIN tier.</a:t>
+            </a:r>
+          </a:p>
+        </p:txBody>
+      </p:sp>
+      <p:sp>
+        <p:nvSpPr>
+          <p:cNvPr id="8" name="Rounded Rectangle 7"/>
+          <p:cNvSpPr/>
+          <p:nvPr/>
+        </p:nvSpPr>
+        <p:spPr>
+          <a:xfrm>
+            <a:off x="566928" y="4718304"/>
+            <a:ext cx="5440680" cy="1325880"/>
+          </a:xfrm>
+          <a:prstGeom prst="roundRect">
+            <a:avLst/>
+          </a:prstGeom>
+          <a:solidFill>
+            <a:srgbClr val="141A2E"/>
+          </a:solidFill>
+          <a:ln w="6350">
+            <a:solidFill>
+              <a:srgbClr val="7C7FF2"/>
+            </a:solidFill>
+          </a:ln>
+          <a:effectLst/>
+        </p:spPr>
+        <p:style>
+          <a:lnRef idx="1">
+            <a:schemeClr val="accent1"/>
+          </a:lnRef>
+          <a:fillRef idx="3">
+            <a:schemeClr val="accent1"/>
+          </a:fillRef>
+          <a:effectRef idx="2">
+            <a:schemeClr val="accent1"/>
+          </a:effectRef>
+          <a:fontRef idx="minor">
+            <a:schemeClr val="lt1"/>
+          </a:fontRef>
+        </p:style>
+        <p:txBody>
+          <a:bodyPr wrap="square" lIns="201168" tIns="128016" rIns="201168" rtlCol="0" anchor="ctr"/>
+          <a:lstStyle/>
+          <a:p>
+            <a:pPr algn="ctr"/>
+            <a:r>
+              <a:rPr sz="1550" b="1">
+                <a:solidFill>
+                  <a:srgbClr val="7C7FF2"/>
+                </a:solidFill>
+                <a:latin typeface="Arial"/>
+              </a:rPr>
+              <a:t>Deeper proactivity</a:t>
+            </a:r>
+          </a:p>
+          <a:p>
+            <a:pPr>
+              <a:spcBef>
+                <a:spcPts val="300"/>
+              </a:spcBef>
+            </a:pPr>
+            <a:r>
+              <a:rPr sz="1250">
+                <a:solidFill>
+                  <a:srgbClr val="F4F5FF"/>
+                </a:solidFill>
+                <a:latin typeface="Calibri"/>
+              </a:rPr>
+              <a:t>Per-member personalized digests · event-driven triggers, not just the morning cron.</a:t>
+            </a:r>
+          </a:p>
+        </p:txBody>
+      </p:sp>
+      <p:sp>
+        <p:nvSpPr>
+          <p:cNvPr id="9" name="Rounded Rectangle 8"/>
+          <p:cNvSpPr/>
+          <p:nvPr/>
+        </p:nvSpPr>
+        <p:spPr>
+          <a:xfrm>
+            <a:off x="6327648" y="4718304"/>
+            <a:ext cx="5440680" cy="1325880"/>
+          </a:xfrm>
+          <a:prstGeom prst="roundRect">
+            <a:avLst/>
+          </a:prstGeom>
+          <a:solidFill>
+            <a:srgbClr val="141A2E"/>
+          </a:solidFill>
+          <a:ln w="6350">
+            <a:solidFill>
+              <a:srgbClr val="7C7FF2"/>
+            </a:solidFill>
+          </a:ln>
+          <a:effectLst/>
+        </p:spPr>
+        <p:style>
+          <a:lnRef idx="1">
+            <a:schemeClr val="accent1"/>
+          </a:lnRef>
+          <a:fillRef idx="3">
+            <a:schemeClr val="accent1"/>
+          </a:fillRef>
+          <a:effectRef idx="2">
+            <a:schemeClr val="accent1"/>
+          </a:effectRef>
+          <a:fontRef idx="minor">
+            <a:schemeClr val="lt1"/>
+          </a:fontRef>
+        </p:style>
+        <p:txBody>
+          <a:bodyPr wrap="square" lIns="201168" tIns="128016" rIns="201168" rtlCol="0" anchor="ctr"/>
+          <a:lstStyle/>
+          <a:p>
+            <a:pPr algn="ctr"/>
+            <a:r>
+              <a:rPr sz="1550" b="1">
+                <a:solidFill>
+                  <a:srgbClr val="7C7FF2"/>
+                </a:solidFill>
+                <a:latin typeface="Arial"/>
+              </a:rPr>
+              <a:t>Same approval gate</a:t>
+            </a:r>
+          </a:p>
+          <a:p>
+            <a:pPr>
+              <a:spcBef>
+                <a:spcPts val="300"/>
+              </a:spcBef>
+            </a:pPr>
+            <a:r>
+              <a:rPr sz="1250">
+                <a:solidFill>
+                  <a:srgbClr val="F4F5FF"/>
+                </a:solidFill>
+                <a:latin typeface="Calibri"/>
+              </a:rPr>
+              <a:t>Every new capability still stages a draft the adult approves.</a:t>
+            </a:r>
+          </a:p>
+        </p:txBody>
+      </p:sp>
+      <p:sp>
+        <p:nvSpPr>
+          <p:cNvPr id="10" name="TextBox 9"/>
+          <p:cNvSpPr txBox="1"/>
+          <p:nvPr/>
+        </p:nvSpPr>
+        <p:spPr>
+          <a:xfrm>
+            <a:off x="548640" y="6355080"/>
+            <a:ext cx="11064240" cy="411480"/>
+          </a:xfrm>
+          <a:prstGeom prst="rect">
+            <a:avLst/>
+          </a:prstGeom>
+          <a:noFill/>
+        </p:spPr>
+        <p:txBody>
+          <a:bodyPr wrap="square">
+            <a:spAutoFit/>
+          </a:bodyPr>
+          <a:lstStyle/>
+          <a:p>
+            <a:pPr algn="ctr"/>
+            <a:r>
+              <a:rPr sz="1300" b="0">
+                <a:solidFill>
+                  <a:srgbClr val="9AA1C0"/>
+                </a:solidFill>
+                <a:latin typeface="Calibri"/>
+              </a:rPr>
+              <a:t>Family-Hub · AGPL open source · github.com/msampath/fam-hub</a:t>
+            </a:r>
           </a:p>
         </p:txBody>
       </p:sp>
@@ -4655,4 +5091,319 @@
     </a:ext>
   </a:extLst>
 </a:theme>
+</file>
+
+<file path=ppt/theme/theme2.xml><?xml version="1.0" encoding="utf-8"?>
+<a:theme xmlns:a="http://schemas.openxmlformats.org/drawingml/2006/main" name="Office Theme">
+  <a:themeElements>
+    <a:clrScheme name="Office">
+      <a:dk1>
+        <a:sysClr val="windowText" lastClr="000000"/>
+      </a:dk1>
+      <a:lt1>
+        <a:sysClr val="window" lastClr="FFFFFF"/>
+      </a:lt1>
+      <a:dk2>
+        <a:srgbClr val="0E2841"/>
+      </a:dk2>
+      <a:lt2>
+        <a:srgbClr val="E8E8E8"/>
+      </a:lt2>
+      <a:accent1>
+        <a:srgbClr val="156082"/>
+      </a:accent1>
+      <a:accent2>
+        <a:srgbClr val="E97132"/>
+      </a:accent2>
+      <a:accent3>
+        <a:srgbClr val="196B24"/>
+      </a:accent3>
+      <a:accent4>
+        <a:srgbClr val="0F9ED5"/>
+      </a:accent4>
+      <a:accent5>
+        <a:srgbClr val="A02B93"/>
+      </a:accent5>
+      <a:accent6>
+        <a:srgbClr val="4EA72E"/>
+      </a:accent6>
+      <a:hlink>
+        <a:srgbClr val="467886"/>
+      </a:hlink>
+      <a:folHlink>
+        <a:srgbClr val="96607D"/>
+      </a:folHlink>
+    </a:clrScheme>
+    <a:fontScheme name="Office">
+      <a:majorFont>
+        <a:latin typeface="Aptos Display" panose="02110004020202020204"/>
+        <a:ea typeface=""/>
+        <a:cs typeface=""/>
+        <a:font script="Jpan" typeface="游ゴシック Light"/>
+        <a:font script="Hang" typeface="맑은 고딕"/>
+        <a:font script="Hans" typeface="等线 Light"/>
+        <a:font script="Hant" typeface="新細明體"/>
+        <a:font script="Arab" typeface="Times New Roman"/>
+        <a:font script="Hebr" typeface="Times New Roman"/>
+        <a:font script="Thai" typeface="Angsana New"/>
+        <a:font script="Ethi" typeface="Nyala"/>
+        <a:font script="Beng" typeface="Vrinda"/>
+        <a:font script="Gujr" typeface="Shruti"/>
+        <a:font script="Khmr" typeface="MoolBoran"/>
+        <a:font script="Knda" typeface="Tunga"/>
+        <a:font script="Guru" typeface="Raavi"/>
+        <a:font script="Cans" typeface="Euphemia"/>
+        <a:font script="Cher" typeface="Plantagenet Cherokee"/>
+        <a:font script="Yiii" typeface="Microsoft Yi Baiti"/>
+        <a:font script="Tibt" typeface="Microsoft Himalaya"/>
+        <a:font script="Thaa" typeface="MV Boli"/>
+        <a:font script="Deva" typeface="Mangal"/>
+        <a:font script="Telu" typeface="Gautami"/>
+        <a:font script="Taml" typeface="Latha"/>
+        <a:font script="Syrc" typeface="Estrangelo Edessa"/>
+        <a:font script="Orya" typeface="Kalinga"/>
+        <a:font script="Mlym" typeface="Kartika"/>
+        <a:font script="Laoo" typeface="DokChampa"/>
+        <a:font script="Sinh" typeface="Iskoola Pota"/>
+        <a:font script="Mong" typeface="Mongolian Baiti"/>
+        <a:font script="Viet" typeface="Times New Roman"/>
+        <a:font script="Uigh" typeface="Microsoft Uighur"/>
+        <a:font script="Geor" typeface="Sylfaen"/>
+        <a:font script="Armn" typeface="Arial"/>
+        <a:font script="Bugi" typeface="Leelawadee UI"/>
+        <a:font script="Bopo" typeface="Microsoft JhengHei"/>
+        <a:font script="Java" typeface="Javanese Text"/>
+        <a:font script="Lisu" typeface="Segoe UI"/>
+        <a:font script="Mymr" typeface="Myanmar Text"/>
+        <a:font script="Nkoo" typeface="Ebrima"/>
+        <a:font script="Olck" typeface="Nirmala UI"/>
+        <a:font script="Osma" typeface="Ebrima"/>
+        <a:font script="Phag" typeface="Phagspa"/>
+        <a:font script="Syrn" typeface="Estrangelo Edessa"/>
+        <a:font script="Syrj" typeface="Estrangelo Edessa"/>
+        <a:font script="Syre" typeface="Estrangelo Edessa"/>
+        <a:font script="Sora" typeface="Nirmala UI"/>
+        <a:font script="Tale" typeface="Microsoft Tai Le"/>
+        <a:font script="Talu" typeface="Microsoft New Tai Lue"/>
+        <a:font script="Tfng" typeface="Ebrima"/>
+      </a:majorFont>
+      <a:minorFont>
+        <a:latin typeface="Aptos" panose="02110004020202020204"/>
+        <a:ea typeface=""/>
+        <a:cs typeface=""/>
+        <a:font script="Jpan" typeface="游ゴシック"/>
+        <a:font script="Hang" typeface="맑은 고딕"/>
+        <a:font script="Hans" typeface="等线"/>
+        <a:font script="Hant" typeface="新細明體"/>
+        <a:font script="Arab" typeface="Arial"/>
+        <a:font script="Hebr" typeface="Arial"/>
+        <a:font script="Thai" typeface="Cordia New"/>
+        <a:font script="Ethi" typeface="Nyala"/>
+        <a:font script="Beng" typeface="Vrinda"/>
+        <a:font script="Gujr" typeface="Shruti"/>
+        <a:font script="Khmr" typeface="DaunPenh"/>
+        <a:font script="Knda" typeface="Tunga"/>
+        <a:font script="Guru" typeface="Raavi"/>
+        <a:font script="Cans" typeface="Euphemia"/>
+        <a:font script="Cher" typeface="Plantagenet Cherokee"/>
+        <a:font script="Yiii" typeface="Microsoft Yi Baiti"/>
+        <a:font script="Tibt" typeface="Microsoft Himalaya"/>
+        <a:font script="Thaa" typeface="MV Boli"/>
+        <a:font script="Deva" typeface="Mangal"/>
+        <a:font script="Telu" typeface="Gautami"/>
+        <a:font script="Taml" typeface="Latha"/>
+        <a:font script="Syrc" typeface="Estrangelo Edessa"/>
+        <a:font script="Orya" typeface="Kalinga"/>
+        <a:font script="Mlym" typeface="Kartika"/>
+        <a:font script="Laoo" typeface="DokChampa"/>
+        <a:font script="Sinh" typeface="Iskoola Pota"/>
+        <a:font script="Mong" typeface="Mongolian Baiti"/>
+        <a:font script="Viet" typeface="Arial"/>
+        <a:font script="Uigh" typeface="Microsoft Uighur"/>
+        <a:font script="Geor" typeface="Sylfaen"/>
+        <a:font script="Armn" typeface="Arial"/>
+        <a:font script="Bugi" typeface="Leelawadee UI"/>
+        <a:font script="Bopo" typeface="Microsoft JhengHei"/>
+        <a:font script="Java" typeface="Javanese Text"/>
+        <a:font script="Lisu" typeface="Segoe UI"/>
+        <a:font script="Mymr" typeface="Myanmar Text"/>
+        <a:font script="Nkoo" typeface="Ebrima"/>
+        <a:font script="Olck" typeface="Nirmala UI"/>
+        <a:font script="Osma" typeface="Ebrima"/>
+        <a:font script="Phag" typeface="Phagspa"/>
+        <a:font script="Syrn" typeface="Estrangelo Edessa"/>
+        <a:font script="Syrj" typeface="Estrangelo Edessa"/>
+        <a:font script="Syre" typeface="Estrangelo Edessa"/>
+        <a:font script="Sora" typeface="Nirmala UI"/>
+        <a:font script="Tale" typeface="Microsoft Tai Le"/>
+        <a:font script="Talu" typeface="Microsoft New Tai Lue"/>
+        <a:font script="Tfng" typeface="Ebrima"/>
+      </a:minorFont>
+    </a:fontScheme>
+    <a:fmtScheme name="Office">
+      <a:fillStyleLst>
+        <a:solidFill>
+          <a:schemeClr val="phClr"/>
+        </a:solidFill>
+        <a:gradFill rotWithShape="1">
+          <a:gsLst>
+            <a:gs pos="0">
+              <a:schemeClr val="phClr">
+                <a:lumMod val="110000"/>
+                <a:satMod val="105000"/>
+                <a:tint val="67000"/>
+              </a:schemeClr>
+            </a:gs>
+            <a:gs pos="50000">
+              <a:schemeClr val="phClr">
+                <a:lumMod val="105000"/>
+                <a:satMod val="103000"/>
+                <a:tint val="73000"/>
+              </a:schemeClr>
+            </a:gs>
+            <a:gs pos="100000">
+              <a:schemeClr val="phClr">
+                <a:lumMod val="105000"/>
+                <a:satMod val="109000"/>
+                <a:tint val="81000"/>
+              </a:schemeClr>
+            </a:gs>
+          </a:gsLst>
+          <a:lin ang="5400000" scaled="0"/>
+        </a:gradFill>
+        <a:gradFill rotWithShape="1">
+          <a:gsLst>
+            <a:gs pos="0">
+              <a:schemeClr val="phClr">
+                <a:satMod val="103000"/>
+                <a:lumMod val="102000"/>
+                <a:tint val="94000"/>
+              </a:schemeClr>
+            </a:gs>
+            <a:gs pos="50000">
+              <a:schemeClr val="phClr">
+                <a:satMod val="110000"/>
+                <a:lumMod val="100000"/>
+                <a:shade val="100000"/>
+              </a:schemeClr>
+            </a:gs>
+            <a:gs pos="100000">
+              <a:schemeClr val="phClr">
+                <a:lumMod val="99000"/>
+                <a:satMod val="120000"/>
+                <a:shade val="78000"/>
+              </a:schemeClr>
+            </a:gs>
+          </a:gsLst>
+          <a:lin ang="5400000" scaled="0"/>
+        </a:gradFill>
+      </a:fillStyleLst>
+      <a:lnStyleLst>
+        <a:ln w="12700" cap="flat" cmpd="sng" algn="ctr">
+          <a:solidFill>
+            <a:schemeClr val="phClr"/>
+          </a:solidFill>
+          <a:prstDash val="solid"/>
+          <a:miter lim="800000"/>
+        </a:ln>
+        <a:ln w="19050" cap="flat" cmpd="sng" algn="ctr">
+          <a:solidFill>
+            <a:schemeClr val="phClr"/>
+          </a:solidFill>
+          <a:prstDash val="solid"/>
+          <a:miter lim="800000"/>
+        </a:ln>
+        <a:ln w="25400" cap="flat" cmpd="sng" algn="ctr">
+          <a:solidFill>
+            <a:schemeClr val="phClr"/>
+          </a:solidFill>
+          <a:prstDash val="solid"/>
+          <a:miter lim="800000"/>
+        </a:ln>
+      </a:lnStyleLst>
+      <a:effectStyleLst>
+        <a:effectStyle>
+          <a:effectLst/>
+        </a:effectStyle>
+        <a:effectStyle>
+          <a:effectLst/>
+        </a:effectStyle>
+        <a:effectStyle>
+          <a:effectLst>
+            <a:outerShdw blurRad="57150" dist="19050" dir="5400000" algn="ctr" rotWithShape="0">
+              <a:srgbClr val="000000">
+                <a:alpha val="63000"/>
+              </a:srgbClr>
+            </a:outerShdw>
+          </a:effectLst>
+        </a:effectStyle>
+      </a:effectStyleLst>
+      <a:bgFillStyleLst>
+        <a:solidFill>
+          <a:schemeClr val="phClr"/>
+        </a:solidFill>
+        <a:solidFill>
+          <a:schemeClr val="phClr">
+            <a:tint val="95000"/>
+            <a:satMod val="170000"/>
+          </a:schemeClr>
+        </a:solidFill>
+        <a:gradFill rotWithShape="1">
+          <a:gsLst>
+            <a:gs pos="0">
+              <a:schemeClr val="phClr">
+                <a:tint val="93000"/>
+                <a:satMod val="150000"/>
+                <a:shade val="98000"/>
+                <a:lumMod val="102000"/>
+              </a:schemeClr>
+            </a:gs>
+            <a:gs pos="50000">
+              <a:schemeClr val="phClr">
+                <a:tint val="98000"/>
+                <a:satMod val="130000"/>
+                <a:shade val="90000"/>
+                <a:lumMod val="103000"/>
+              </a:schemeClr>
+            </a:gs>
+            <a:gs pos="100000">
+              <a:schemeClr val="phClr">
+                <a:shade val="63000"/>
+                <a:satMod val="120000"/>
+              </a:schemeClr>
+            </a:gs>
+          </a:gsLst>
+          <a:lin ang="5400000" scaled="0"/>
+        </a:gradFill>
+      </a:bgFillStyleLst>
+    </a:fmtScheme>
+  </a:themeElements>
+  <a:objectDefaults>
+    <a:lnDef>
+      <a:spPr/>
+      <a:bodyPr/>
+      <a:lstStyle/>
+      <a:style>
+        <a:lnRef idx="2">
+          <a:schemeClr val="accent1"/>
+        </a:lnRef>
+        <a:fillRef idx="0">
+          <a:schemeClr val="accent1"/>
+        </a:fillRef>
+        <a:effectRef idx="1">
+          <a:schemeClr val="accent1"/>
+        </a:effectRef>
+        <a:fontRef idx="minor">
+          <a:schemeClr val="tx1"/>
+        </a:fontRef>
+      </a:style>
+    </a:lnDef>
+  </a:objectDefaults>
+  <a:extraClrSchemeLst/>
+  <a:extLst>
+    <a:ext uri="{05A4C25C-085E-4340-85A3-A5531E510DB2}">
+      <thm15:themeFamily xmlns:thm15="http://schemas.microsoft.com/office/thememl/2012/main" name="Office Theme" id="{2E142A2C-CD16-42D6-873A-C26D2A0506FA}" vid="{1BDDFF52-6CD6-40A5-AB3C-68EB2F1E4D0A}"/>
+    </a:ext>
+  </a:extLst>
+</a:theme>
 </file>
</xml_diff>

<commit_message>
feat(demo): seed one pending Approval; label staged drafts by surface (Approvals vs Actions)
A fresh judge sandbox never showed the Approvals button (it renders only
with pending/resolved entries), hiding the safety-gate surface the video
leans on. The demo now seeds one pending suggest_event drawn from the
seeded newsletter, so Approvals (1) is visible on arrival and approving
it exercises the booking-payload apply path. The staged-draft toast also
mislabeled handoffs ('review in Approve'): USER_COMPLETES is now a shared
constant and the summary names the real surface per bucket. Script/deck
demo beats updated to the live-validated flow (Rainier = itinerary+goal;
dinner reservation = the handoff with details-to-enter).

Co-Authored-By: Claude Fable 5 <noreply@anthropic.com>
</commit_message>
<xml_diff>
--- a/planning/video-deck.pptx
+++ b/planning/video-deck.pptx
@@ -551,9 +551,10 @@
           <a:lstStyle/>
           <a:p>
             <a:r>
-              <a:rPr lang="en-US" dirty="0"/>
-              <a:t>1:10. Everything risky lands in one place: Approvals. The morning agent's proposals, deletes, event suggestions — approve, modify, or dismiss. Booking handoffs open the venue's real page with the details listed beside it — it never fills the form and never pays. And the whole thing stays in its lane: ask it for homework help and it politely declines.</a:t>
-            </a:r>
+              <a:rPr lang="en-US"/>
+              <a:t>1:10. Two review surfaces, one principle: the adult stays in charge. APPROVALS is everything the copilot will only do once you say yes - the morning agent's proposals, deletes, event suggestions: approve, modify, or dismiss. ACTIONS is the legwork it hands YOU to finish - booking handoffs that open the venue's real page with the details the form will ask for listed beside it. It never fills the form and never pays. And the whole thing stays in its lane: ask it for homework help and it politely declines.</a:t>
+            </a:r>
+            <a:endParaRPr lang="en-US" dirty="0"/>
           </a:p>
         </p:txBody>
       </p:sp>
@@ -4142,7 +4143,18 @@
                 <a:ea typeface="Calibri" pitchFamily="34" charset="-122"/>
                 <a:cs typeface="Calibri" pitchFamily="34" charset="-120"/>
               </a:rPr>
-              <a:t>③  “Plan a Mount Rainier day trip next weekend, track it as a goal” → goal strip + verified handoff</a:t>
+              <a:t>③  “Plan a Mount Rainier day trip next weekend</a:t>
+            </a:r>
+            <a:r>
+              <a:rPr lang="en-US" sz="1650">
+                <a:solidFill>
+                  <a:srgbClr val="F4F5FF"/>
+                </a:solidFill>
+                <a:latin typeface="Calibri" pitchFamily="34" charset="0"/>
+                <a:ea typeface="Calibri" pitchFamily="34" charset="-122"/>
+                <a:cs typeface="Calibri" pitchFamily="34" charset="-120"/>
+              </a:rPr>
+              <a:t>, track it as a goal” → goal strip + grounded itinerary</a:t>
             </a:r>
             <a:endParaRPr lang="en-US" sz="1650" dirty="0"/>
           </a:p>
@@ -4154,7 +4166,7 @@
               <a:buNone/>
             </a:pPr>
             <a:r>
-              <a:rPr lang="en-US" sz="1650" dirty="0">
+              <a:rPr lang="en-US" sz="1650">
                 <a:solidFill>
                   <a:srgbClr val="F4F5FF"/>
                 </a:solidFill>
@@ -4162,7 +4174,7 @@
                 <a:ea typeface="Calibri" pitchFamily="34" charset="-122"/>
                 <a:cs typeface="Calibri" pitchFamily="34" charset="-120"/>
               </a:rPr>
-              <a:t>④  “Buy the tickets and pay with our card” → the refusal — no tool it could call</a:t>
+              <a:t>④  “Book a dinner table for 4 Saturday 7pm” → Actions handoff · “pay for it” → the refusal</a:t>
             </a:r>
             <a:endParaRPr lang="en-US" sz="1650" dirty="0"/>
           </a:p>

</xml_diff>

<commit_message>
docs(deck): 'Intent → a real grocery cart' slide + fact fixes (10 slides)
New slide 7 (ADDED IN-WINDOW), deck-styled, with the two live screenshots
embedded — the line-per-item Approvals card and the resulting fredmeyer.com
cart (owner-run, 2026-07-06). Notes flag it as post-recording, in-window.
Fact fixes on existing slides: THE BUILD test counts 925/30 → 1,191/37;
WHAT'S NEXT roadmap card 'Kroger cart integration' → 'Instacart adapter
(next)' since the Kroger loop shipped. Footer on the new slide states the
hosted demo runs the submission-freeze build.

Co-Authored-By: Claude Fable 5 <noreply@anthropic.com>
</commit_message>
<xml_diff>
--- a/planning/video-deck.pptx
+++ b/planning/video-deck.pptx
@@ -14,6 +14,7 @@
     <p:sldId id="259" r:id="rId5"/>
     <p:sldId id="260" r:id="rId6"/>
     <p:sldId id="261" r:id="rId7"/>
+    <p:sldId id="265" r:id="rId16"/>
     <p:sldId id="262" r:id="rId8"/>
     <p:sldId id="263" r:id="rId9"/>
     <p:sldId id="264" r:id="rId10"/>
@@ -325,6 +326,52 @@
         <p14:creationId xmlns:p14="http://schemas.microsoft.com/office/powerpoint/2010/main" val="1024086991"/>
       </p:ext>
     </p:extLst>
+  </p:cSld>
+  <p:clrMapOvr>
+    <a:masterClrMapping/>
+  </p:clrMapOvr>
+</p:notes>
+</file>
+
+<file path=ppt/notesSlides/notesSlide10.xml><?xml version="1.0" encoding="utf-8"?>
+<p:notes xmlns:a="http://schemas.openxmlformats.org/drawingml/2006/main" xmlns:p="http://schemas.openxmlformats.org/presentationml/2006/main" xmlns:r="http://schemas.openxmlformats.org/officeDocument/2006/relationships">
+  <p:cSld>
+    <p:spTree>
+      <p:nvGrpSpPr>
+        <p:cNvPr id="1" name=""/>
+        <p:cNvGrpSpPr/>
+        <p:nvPr/>
+      </p:nvGrpSpPr>
+      <p:grpSpPr>
+        <a:xfrm>
+          <a:off x="0" y="0"/>
+          <a:ext cx="0" cy="0"/>
+          <a:chOff x="0" y="0"/>
+          <a:chExt cx="0" cy="0"/>
+        </a:xfrm>
+      </p:grpSpPr>
+      <p:sp>
+        <p:nvSpPr>
+          <p:cNvPr id="3" name="Notes Placeholder 2"/>
+          <p:cNvSpPr>
+            <a:spLocks noGrp="1"/>
+          </p:cNvSpPr>
+          <p:nvPr>
+            <p:ph type="body" idx="1"/>
+          </p:nvPr>
+        </p:nvSpPr>
+        <p:spPr/>
+        <p:txBody>
+          <a:bodyPr/>
+          <a:lstStyle/>
+          <a:p>
+            <a:r>
+              <a:t>[Added after the video was recorded — in-window, public on the repo; not narrated in the recording.] The concierge’s first fully CLOSED loop: intent to a real-world state change. Ingredients derived in buy units, matched pick-or-decline against the store’s live catalog (schema-enforced; out-of-stock dropped; low-confidence declines re-judged once), one line-per-item approval, then the items appear in the actual Fred Meyer cart — payment structurally impossible (the public Kroger API has no checkout endpoint). Screenshots: the Approvals card and the live fredmeyer.com cart, 2026-07-06. Setup: docs/kroger-setup.md.</a:t>
+            </a:r>
+          </a:p>
+        </p:txBody>
+      </p:sp>
+    </p:spTree>
   </p:cSld>
   <p:clrMapOvr>
     <a:masterClrMapping/>
@@ -1409,6 +1456,10 @@
           </a:solidFill>
           <a:ln/>
         </p:spPr>
+        <p:txBody>
+          <a:bodyPr/>
+          <a:p/>
+        </p:txBody>
       </p:sp>
       <p:sp>
         <p:nvSpPr>
@@ -1552,6 +1603,305 @@
               <a:t>Kaggle AI Agents Capstone · Concierge track</a:t>
             </a:r>
             <a:endParaRPr lang="en-US" sz="1300" dirty="0"/>
+          </a:p>
+        </p:txBody>
+      </p:sp>
+    </p:spTree>
+  </p:cSld>
+  <p:clrMapOvr>
+    <a:masterClrMapping/>
+  </p:clrMapOvr>
+</p:sld>
+</file>
+
+<file path=ppt/slides/slide10.xml><?xml version="1.0" encoding="utf-8"?>
+<p:sld xmlns:a="http://schemas.openxmlformats.org/drawingml/2006/main" xmlns:p="http://schemas.openxmlformats.org/presentationml/2006/main" xmlns:r="http://schemas.openxmlformats.org/officeDocument/2006/relationships">
+  <p:cSld>
+    <p:bg>
+      <p:bgPr>
+        <a:solidFill>
+          <a:srgbClr val="0B0F1A"/>
+        </a:solidFill>
+        <a:effectLst/>
+      </p:bgPr>
+    </p:bg>
+    <p:spTree>
+      <p:nvGrpSpPr>
+        <p:cNvPr id="1" name=""/>
+        <p:cNvGrpSpPr/>
+        <p:nvPr/>
+      </p:nvGrpSpPr>
+      <p:grpSpPr/>
+      <p:sp>
+        <p:nvSpPr>
+          <p:cNvPr id="2" name="TextBox 1"/>
+          <p:cNvSpPr txBox="1"/>
+          <p:nvPr/>
+        </p:nvSpPr>
+        <p:spPr>
+          <a:xfrm>
+            <a:off x="548640" y="91440"/>
+            <a:ext cx="9144000" cy="274320"/>
+          </a:xfrm>
+          <a:prstGeom prst="rect">
+            <a:avLst/>
+          </a:prstGeom>
+          <a:noFill/>
+        </p:spPr>
+        <p:txBody>
+          <a:bodyPr wrap="square">
+            <a:spAutoFit/>
+          </a:bodyPr>
+          <a:lstStyle/>
+          <a:p>
+            <a:r>
+              <a:rPr sz="1200" b="1">
+                <a:solidFill>
+                  <a:srgbClr val="7C7FF2"/>
+                </a:solidFill>
+                <a:latin typeface="Arial"/>
+              </a:rPr>
+              <a:t>ADDED IN-WINDOW</a:t>
+            </a:r>
+          </a:p>
+        </p:txBody>
+      </p:sp>
+      <p:sp>
+        <p:nvSpPr>
+          <p:cNvPr id="3" name="TextBox 2"/>
+          <p:cNvSpPr txBox="1"/>
+          <p:nvPr/>
+        </p:nvSpPr>
+        <p:spPr>
+          <a:xfrm>
+            <a:off x="548640" y="457200"/>
+            <a:ext cx="11064240" cy="731520"/>
+          </a:xfrm>
+          <a:prstGeom prst="rect">
+            <a:avLst/>
+          </a:prstGeom>
+          <a:noFill/>
+        </p:spPr>
+        <p:txBody>
+          <a:bodyPr wrap="square">
+            <a:spAutoFit/>
+          </a:bodyPr>
+          <a:lstStyle/>
+          <a:p>
+            <a:r>
+              <a:rPr sz="3400" b="1">
+                <a:solidFill>
+                  <a:srgbClr val="F4F5FF"/>
+                </a:solidFill>
+                <a:latin typeface="Arial"/>
+              </a:rPr>
+              <a:t>Intent → a real grocery cart</a:t>
+            </a:r>
+          </a:p>
+        </p:txBody>
+      </p:sp>
+      <p:sp>
+        <p:nvSpPr>
+          <p:cNvPr id="4" name="TextBox 3"/>
+          <p:cNvSpPr txBox="1"/>
+          <p:nvPr/>
+        </p:nvSpPr>
+        <p:spPr>
+          <a:xfrm>
+            <a:off x="548640" y="1554480"/>
+            <a:ext cx="5486400" cy="4937760"/>
+          </a:xfrm>
+          <a:prstGeom prst="rect">
+            <a:avLst/>
+          </a:prstGeom>
+          <a:noFill/>
+        </p:spPr>
+        <p:txBody>
+          <a:bodyPr wrap="square">
+            <a:spAutoFit/>
+          </a:bodyPr>
+          <a:lstStyle/>
+          <a:p>
+            <a:pPr>
+              <a:spcAft>
+                <a:spcPts val="1400"/>
+              </a:spcAft>
+            </a:pPr>
+            <a:r>
+              <a:rPr sz="1700" b="1">
+                <a:solidFill>
+                  <a:srgbClr val="7C7FF2"/>
+                </a:solidFill>
+                <a:latin typeface="Calibri"/>
+              </a:rPr>
+              <a:t>One approval away. </a:t>
+            </a:r>
+            <a:r>
+              <a:rPr sz="1700" b="0">
+                <a:solidFill>
+                  <a:srgbClr val="F4F5FF"/>
+                </a:solidFill>
+                <a:latin typeface="Calibri"/>
+              </a:rPr>
+              <a:t>“I want paneer butter masala” → buy-unit ingredients → per-list Send → items in the family’s actual Fred Meyer cart.</a:t>
+            </a:r>
+          </a:p>
+          <a:p>
+            <a:pPr>
+              <a:spcAft>
+                <a:spcPts val="1400"/>
+              </a:spcAft>
+            </a:pPr>
+            <a:r>
+              <a:rPr sz="1700" b="1">
+                <a:solidFill>
+                  <a:srgbClr val="F2B84B"/>
+                </a:solidFill>
+                <a:latin typeface="Calibri"/>
+              </a:rPr>
+              <a:t>Pick-or-decline matching. </a:t>
+            </a:r>
+            <a:r>
+              <a:rPr sz="1700" b="0">
+                <a:solidFill>
+                  <a:srgbClr val="F4F5FF"/>
+                </a:solidFill>
+                <a:latin typeface="Calibri"/>
+              </a:rPr>
+              <a:t>Kroger search returns frying pans for “paneer” — the model must choose from the store’s real candidates or say no; declines get one second look.</a:t>
+            </a:r>
+          </a:p>
+          <a:p>
+            <a:pPr>
+              <a:spcAft>
+                <a:spcPts val="1400"/>
+              </a:spcAft>
+            </a:pPr>
+            <a:r>
+              <a:rPr sz="1700" b="1">
+                <a:solidFill>
+                  <a:srgbClr val="7C7FF2"/>
+                </a:solidFill>
+                <a:latin typeface="Calibri"/>
+              </a:rPr>
+              <a:t>Honest per-item reasons. </a:t>
+            </a:r>
+            <a:r>
+              <a:rPr sz="1700" b="0">
+                <a:solidFill>
+                  <a:srgbClr val="F4F5FF"/>
+                </a:solidFill>
+                <a:latin typeface="Calibri"/>
+              </a:rPr>
+              <a:t>no match at this store ≠ couldn’t confidently match ≠ search failed — unmatched items stay on the list.</a:t>
+            </a:r>
+          </a:p>
+          <a:p>
+            <a:pPr>
+              <a:spcAft>
+                <a:spcPts val="1400"/>
+              </a:spcAft>
+            </a:pPr>
+            <a:r>
+              <a:rPr sz="1700" b="1">
+                <a:solidFill>
+                  <a:srgbClr val="F2B84B"/>
+                </a:solidFill>
+                <a:latin typeface="Calibri"/>
+              </a:rPr>
+              <a:t>Still no payment tool. </a:t>
+            </a:r>
+            <a:r>
+              <a:rPr sz="1700" b="0">
+                <a:solidFill>
+                  <a:srgbClr val="F4F5FF"/>
+                </a:solidFill>
+                <a:latin typeface="Calibri"/>
+              </a:rPr>
+              <a:t>The public API has no checkout endpoint — the parent pays in Kroger’s own app. Setup: docs/kroger-setup.md.</a:t>
+            </a:r>
+          </a:p>
+        </p:txBody>
+      </p:sp>
+      <p:pic>
+        <p:nvPicPr>
+          <p:cNvPr id="5" name="Picture 4" descr="Screenshot 2026-07-06 142153.png"/>
+          <p:cNvPicPr>
+            <a:picLocks noChangeAspect="1"/>
+          </p:cNvPicPr>
+          <p:nvPr/>
+        </p:nvPicPr>
+        <p:blipFill>
+          <a:blip r:embed="rId2"/>
+          <a:stretch>
+            <a:fillRect/>
+          </a:stretch>
+        </p:blipFill>
+        <p:spPr>
+          <a:xfrm>
+            <a:off x="7319304" y="1371600"/>
+            <a:ext cx="3375071" cy="2377440"/>
+          </a:xfrm>
+          <a:prstGeom prst="rect">
+            <a:avLst/>
+          </a:prstGeom>
+        </p:spPr>
+      </p:pic>
+      <p:pic>
+        <p:nvPicPr>
+          <p:cNvPr id="6" name="Picture 5" descr="Screenshot 2026-07-06 142309.png"/>
+          <p:cNvPicPr>
+            <a:picLocks noChangeAspect="1"/>
+          </p:cNvPicPr>
+          <p:nvPr/>
+        </p:nvPicPr>
+        <p:blipFill>
+          <a:blip r:embed="rId3"/>
+          <a:stretch>
+            <a:fillRect/>
+          </a:stretch>
+        </p:blipFill>
+        <p:spPr>
+          <a:xfrm>
+            <a:off x="7116824" y="3913632"/>
+            <a:ext cx="3780030" cy="2377440"/>
+          </a:xfrm>
+          <a:prstGeom prst="rect">
+            <a:avLst/>
+          </a:prstGeom>
+        </p:spPr>
+      </p:pic>
+      <p:sp>
+        <p:nvSpPr>
+          <p:cNvPr id="7" name="TextBox 6"/>
+          <p:cNvSpPr txBox="1"/>
+          <p:nvPr/>
+        </p:nvSpPr>
+        <p:spPr>
+          <a:xfrm>
+            <a:off x="548640" y="6400800"/>
+            <a:ext cx="11064240" cy="365760"/>
+          </a:xfrm>
+          <a:prstGeom prst="rect">
+            <a:avLst/>
+          </a:prstGeom>
+          <a:noFill/>
+        </p:spPr>
+        <p:txBody>
+          <a:bodyPr wrap="square">
+            <a:spAutoFit/>
+          </a:bodyPr>
+          <a:lstStyle/>
+          <a:p>
+            <a:r>
+              <a:rPr sz="1100" b="0">
+                <a:solidFill>
+                  <a:srgbClr val="9AA1C0"/>
+                </a:solidFill>
+                <a:latin typeface="Calibri"/>
+              </a:rPr>
+              <a:t>Owner-verified live 2026-07-06 · the hosted demo runs the submission-freeze build — this loop ships on the repo’s default branch with tests + setup guide</a:t>
+            </a:r>
           </a:p>
         </p:txBody>
       </p:sp>
@@ -1979,6 +2329,10 @@
             <a:prstDash val="solid"/>
           </a:ln>
         </p:spPr>
+        <p:txBody>
+          <a:bodyPr/>
+          <a:p/>
+        </p:txBody>
       </p:sp>
       <p:sp>
         <p:nvSpPr>
@@ -2045,6 +2399,10 @@
             <a:prstDash val="solid"/>
           </a:ln>
         </p:spPr>
+        <p:txBody>
+          <a:bodyPr/>
+          <a:p/>
+        </p:txBody>
       </p:sp>
       <p:sp>
         <p:nvSpPr>
@@ -2145,6 +2503,10 @@
             <a:prstDash val="solid"/>
           </a:ln>
         </p:spPr>
+        <p:txBody>
+          <a:bodyPr/>
+          <a:p/>
+        </p:txBody>
       </p:sp>
       <p:sp>
         <p:nvSpPr>
@@ -2245,6 +2607,10 @@
             <a:prstDash val="solid"/>
           </a:ln>
         </p:spPr>
+        <p:txBody>
+          <a:bodyPr/>
+          <a:p/>
+        </p:txBody>
       </p:sp>
       <p:sp>
         <p:nvSpPr>
@@ -2345,6 +2711,10 @@
             <a:prstDash val="solid"/>
           </a:ln>
         </p:spPr>
+        <p:txBody>
+          <a:bodyPr/>
+          <a:p/>
+        </p:txBody>
       </p:sp>
       <p:sp>
         <p:nvSpPr>
@@ -3577,6 +3947,10 @@
           </a:solidFill>
           <a:ln/>
         </p:spPr>
+        <p:txBody>
+          <a:bodyPr/>
+          <a:p/>
+        </p:txBody>
       </p:sp>
       <p:sp>
         <p:nvSpPr>
@@ -3677,6 +4051,10 @@
           </a:solidFill>
           <a:ln/>
         </p:spPr>
+        <p:txBody>
+          <a:bodyPr/>
+          <a:p/>
+        </p:txBody>
       </p:sp>
       <p:sp>
         <p:nvSpPr>
@@ -3799,6 +4177,10 @@
           </a:solidFill>
           <a:ln/>
         </p:spPr>
+        <p:txBody>
+          <a:bodyPr/>
+          <a:p/>
+        </p:txBody>
       </p:sp>
       <p:sp>
         <p:nvSpPr>
@@ -3950,7 +4332,7 @@
                 <a:ea typeface="Calibri" pitchFamily="34" charset="-122"/>
                 <a:cs typeface="Calibri" pitchFamily="34" charset="-120"/>
               </a:rPr>
-              <a:t>925 frontend tests · 30 agent tests · deployable three ways: Cloud Run, docker compose, Raspberry Pi</a:t>
+              <a:t>1,191 frontend tests · 37 agent tests · deployable three ways: Cloud Run, docker compose, Raspberry Pi</a:t>
             </a:r>
             <a:endParaRPr lang="en-US" sz="1500" dirty="0"/>
           </a:p>
@@ -4391,7 +4773,7 @@
                 </a:solidFill>
                 <a:latin typeface="Arial"/>
               </a:rPr>
-              <a:t>Kroger cart integration</a:t>
+              <a:t>Instacart adapter (next)</a:t>
             </a:r>
           </a:p>
           <a:p>
@@ -4407,7 +4789,7 @@
                 </a:solidFill>
                 <a:latin typeface="Calibri"/>
               </a:rPr>
-              <a:t>“paneer butter masala” → one approved draft fills the QFC cart. Kroger’s API has no payment endpoint — the invariant holds by contract.</a:t>
+              <a:t>Kroger loop SHIPPED in-window — next retailer is a second connection card: shoppable lists across 1,500+ banners (covers Costco)</a:t>
             </a:r>
           </a:p>
         </p:txBody>

</xml_diff>

<commit_message>
docs(deck): fold the meal planner into the in-window slide (plan -> cart chain)
Co-Authored-By: Claude Fable 5 <noreply@anthropic.com>
</commit_message>
<xml_diff>
--- a/planning/video-deck.pptx
+++ b/planning/video-deck.pptx
@@ -366,7 +366,7 @@
           <a:lstStyle/>
           <a:p>
             <a:r>
-              <a:t>[Added after the video was recorded — in-window, public on the repo; not narrated in the recording.] The concierge’s first fully CLOSED loop: intent to a real-world state change. Ingredients derived in buy units, matched pick-or-decline against the store’s live catalog (schema-enforced; out-of-stock dropped; low-confidence declines re-judged once), one line-per-item approval, then the items appear in the actual Fred Meyer cart — payment structurally impossible (the public Kroger API has no checkout endpoint). Screenshots: the Approvals card and the live fredmeyer.com cart, 2026-07-06. Setup: docs/kroger-setup.md.</a:t>
+              <a:t>[Added after the video — in-window, public on the repo.] The chain: a WEEK planned (diet-aware, next-7-days, full CRUD) → one consolidated store-routed shopping list → pick-or-decline product matching → one approval → items in the real Fred Meyer cart (the public Kroger API has no checkout endpoint). Screenshots: the lunch plan + strip, the approval card, the fredmeyer.com cart.</a:t>
             </a:r>
           </a:p>
         </p:txBody>
@@ -1615,7 +1615,7 @@
 </file>
 
 <file path=ppt/slides/slide10.xml><?xml version="1.0" encoding="utf-8"?>
-<p:sld xmlns:a="http://schemas.openxmlformats.org/drawingml/2006/main" xmlns:p="http://schemas.openxmlformats.org/presentationml/2006/main" xmlns:r="http://schemas.openxmlformats.org/officeDocument/2006/relationships">
+<p:sld xmlns:a="http://schemas.openxmlformats.org/drawingml/2006/main" xmlns:r="http://schemas.openxmlformats.org/officeDocument/2006/relationships" xmlns:p="http://schemas.openxmlformats.org/presentationml/2006/main">
   <p:cSld>
     <p:bg>
       <p:bgPr>
@@ -1631,7 +1631,14 @@
         <p:cNvGrpSpPr/>
         <p:nvPr/>
       </p:nvGrpSpPr>
-      <p:grpSpPr/>
+      <p:grpSpPr>
+        <a:xfrm>
+          <a:off x="0" y="0"/>
+          <a:ext cx="0" cy="0"/>
+          <a:chOff x="0" y="0"/>
+          <a:chExt cx="0" cy="0"/>
+        </a:xfrm>
+      </p:grpSpPr>
       <p:sp>
         <p:nvSpPr>
           <p:cNvPr id="2" name="TextBox 1"/>
@@ -1640,8 +1647,8 @@
         </p:nvSpPr>
         <p:spPr>
           <a:xfrm>
-            <a:off x="548640" y="91440"/>
-            <a:ext cx="9144000" cy="274320"/>
+            <a:off x="566928" y="109728"/>
+            <a:ext cx="9144000" cy="320040"/>
           </a:xfrm>
           <a:prstGeom prst="rect">
             <a:avLst/>
@@ -1654,6 +1661,7 @@
           </a:bodyPr>
           <a:lstStyle/>
           <a:p>
+            <a:pPr algn="l"/>
             <a:r>
               <a:rPr sz="1200" b="1">
                 <a:solidFill>
@@ -1661,7 +1669,7 @@
                 </a:solidFill>
                 <a:latin typeface="Arial"/>
               </a:rPr>
-              <a:t>ADDED IN-WINDOW</a:t>
+              <a:t>WHAT’S NEXT</a:t>
             </a:r>
           </a:p>
         </p:txBody>
@@ -1674,8 +1682,8 @@
         </p:nvSpPr>
         <p:spPr>
           <a:xfrm>
-            <a:off x="548640" y="457200"/>
-            <a:ext cx="11064240" cy="731520"/>
+            <a:off x="548640" y="411480"/>
+            <a:ext cx="11064240" cy="777240"/>
           </a:xfrm>
           <a:prstGeom prst="rect">
             <a:avLst/>
@@ -1688,6 +1696,7 @@
           </a:bodyPr>
           <a:lstStyle/>
           <a:p>
+            <a:pPr algn="l"/>
             <a:r>
               <a:rPr sz="3400" b="1">
                 <a:solidFill>
@@ -1695,21 +1704,447 @@
                 </a:solidFill>
                 <a:latin typeface="Arial"/>
               </a:rPr>
-              <a:t>Intent → a real grocery cart</a:t>
-            </a:r>
-          </a:p>
-        </p:txBody>
-      </p:sp>
-      <p:sp>
-        <p:nvSpPr>
-          <p:cNvPr id="4" name="TextBox 3"/>
+              <a:t>This week’s roadmap — same safety spine</a:t>
+            </a:r>
+          </a:p>
+        </p:txBody>
+      </p:sp>
+      <p:sp>
+        <p:nvSpPr>
+          <p:cNvPr id="4" name="Rounded Rectangle 3"/>
+          <p:cNvSpPr/>
+          <p:nvPr/>
+        </p:nvSpPr>
+        <p:spPr>
+          <a:xfrm>
+            <a:off x="566928" y="1554480"/>
+            <a:ext cx="5440680" cy="1325880"/>
+          </a:xfrm>
+          <a:prstGeom prst="roundRect">
+            <a:avLst/>
+          </a:prstGeom>
+          <a:solidFill>
+            <a:srgbClr val="141A2E"/>
+          </a:solidFill>
+          <a:ln w="6350">
+            <a:solidFill>
+              <a:srgbClr val="7C7FF2"/>
+            </a:solidFill>
+          </a:ln>
+          <a:effectLst/>
+        </p:spPr>
+        <p:style>
+          <a:lnRef idx="1">
+            <a:schemeClr val="accent1"/>
+          </a:lnRef>
+          <a:fillRef idx="3">
+            <a:schemeClr val="accent1"/>
+          </a:fillRef>
+          <a:effectRef idx="2">
+            <a:schemeClr val="accent1"/>
+          </a:effectRef>
+          <a:fontRef idx="minor">
+            <a:schemeClr val="lt1"/>
+          </a:fontRef>
+        </p:style>
+        <p:txBody>
+          <a:bodyPr wrap="square" lIns="201168" tIns="128016" rIns="201168" rtlCol="0" anchor="ctr"/>
+          <a:lstStyle/>
+          <a:p>
+            <a:pPr algn="ctr"/>
+            <a:r>
+              <a:rPr sz="1550" b="1">
+                <a:solidFill>
+                  <a:srgbClr val="F2B84B"/>
+                </a:solidFill>
+                <a:latin typeface="Arial"/>
+              </a:rPr>
+              <a:t>Instacart adapter (next)</a:t>
+            </a:r>
+          </a:p>
+          <a:p>
+            <a:pPr>
+              <a:spcBef>
+                <a:spcPts val="300"/>
+              </a:spcBef>
+            </a:pPr>
+            <a:r>
+              <a:rPr sz="1250">
+                <a:solidFill>
+                  <a:srgbClr val="F4F5FF"/>
+                </a:solidFill>
+                <a:latin typeface="Calibri"/>
+              </a:rPr>
+              <a:t>Kroger loop SHIPPED in-window — next retailer is a second connection card: shoppable lists across 1,500+ banners (covers Costco)</a:t>
+            </a:r>
+          </a:p>
+        </p:txBody>
+      </p:sp>
+      <p:sp>
+        <p:nvSpPr>
+          <p:cNvPr id="5" name="Rounded Rectangle 4"/>
+          <p:cNvSpPr/>
+          <p:nvPr/>
+        </p:nvSpPr>
+        <p:spPr>
+          <a:xfrm>
+            <a:off x="6327648" y="1554480"/>
+            <a:ext cx="5440680" cy="1325880"/>
+          </a:xfrm>
+          <a:prstGeom prst="roundRect">
+            <a:avLst/>
+          </a:prstGeom>
+          <a:solidFill>
+            <a:srgbClr val="141A2E"/>
+          </a:solidFill>
+          <a:ln w="6350">
+            <a:solidFill>
+              <a:srgbClr val="7C7FF2"/>
+            </a:solidFill>
+          </a:ln>
+          <a:effectLst/>
+        </p:spPr>
+        <p:style>
+          <a:lnRef idx="1">
+            <a:schemeClr val="accent1"/>
+          </a:lnRef>
+          <a:fillRef idx="3">
+            <a:schemeClr val="accent1"/>
+          </a:fillRef>
+          <a:effectRef idx="2">
+            <a:schemeClr val="accent1"/>
+          </a:effectRef>
+          <a:fontRef idx="minor">
+            <a:schemeClr val="lt1"/>
+          </a:fontRef>
+        </p:style>
+        <p:txBody>
+          <a:bodyPr wrap="square" lIns="201168" tIns="128016" rIns="201168" rtlCol="0" anchor="ctr"/>
+          <a:lstStyle/>
+          <a:p>
+            <a:pPr algn="ctr"/>
+            <a:r>
+              <a:rPr sz="1550" b="1">
+                <a:solidFill>
+                  <a:srgbClr val="F2B84B"/>
+                </a:solidFill>
+                <a:latin typeface="Arial"/>
+              </a:rPr>
+              <a:t>$0 private mode</a:t>
+            </a:r>
+          </a:p>
+          <a:p>
+            <a:pPr>
+              <a:spcBef>
+                <a:spcPts val="300"/>
+              </a:spcBef>
+            </a:pPr>
+            <a:r>
+              <a:rPr sz="1250">
+                <a:solidFill>
+                  <a:srgbClr val="F4F5FF"/>
+                </a:solidFill>
+                <a:latin typeface="Calibri"/>
+              </a:rPr>
+              <a:t>gpt-oss:20b running locally on the home box — no cloud, no bill. Eval-gated before it ever serves the family.</a:t>
+            </a:r>
+          </a:p>
+        </p:txBody>
+      </p:sp>
+      <p:sp>
+        <p:nvSpPr>
+          <p:cNvPr id="6" name="Rounded Rectangle 5"/>
+          <p:cNvSpPr/>
+          <p:nvPr/>
+        </p:nvSpPr>
+        <p:spPr>
+          <a:xfrm>
+            <a:off x="566928" y="3136391"/>
+            <a:ext cx="5440680" cy="1325880"/>
+          </a:xfrm>
+          <a:prstGeom prst="roundRect">
+            <a:avLst/>
+          </a:prstGeom>
+          <a:solidFill>
+            <a:srgbClr val="141A2E"/>
+          </a:solidFill>
+          <a:ln w="6350">
+            <a:solidFill>
+              <a:srgbClr val="7C7FF2"/>
+            </a:solidFill>
+          </a:ln>
+          <a:effectLst/>
+        </p:spPr>
+        <p:style>
+          <a:lnRef idx="1">
+            <a:schemeClr val="accent1"/>
+          </a:lnRef>
+          <a:fillRef idx="3">
+            <a:schemeClr val="accent1"/>
+          </a:fillRef>
+          <a:effectRef idx="2">
+            <a:schemeClr val="accent1"/>
+          </a:effectRef>
+          <a:fontRef idx="minor">
+            <a:schemeClr val="lt1"/>
+          </a:fontRef>
+        </p:style>
+        <p:txBody>
+          <a:bodyPr wrap="square" lIns="201168" tIns="128016" rIns="201168" rtlCol="0" anchor="ctr"/>
+          <a:lstStyle/>
+          <a:p>
+            <a:pPr algn="ctr"/>
+            <a:r>
+              <a:rPr sz="1550" b="1">
+                <a:solidFill>
+                  <a:srgbClr val="7C7FF2"/>
+                </a:solidFill>
+                <a:latin typeface="Arial"/>
+              </a:rPr>
+              <a:t>Household-defined store lists</a:t>
+            </a:r>
+          </a:p>
+          <a:p>
+            <a:pPr>
+              <a:spcBef>
+                <a:spcPts val="300"/>
+              </a:spcBef>
+            </a:pPr>
+            <a:r>
+              <a:rPr sz="1250">
+                <a:solidFill>
+                  <a:srgbClr val="F4F5FF"/>
+                </a:solidFill>
+                <a:latin typeface="Calibri"/>
+              </a:rPr>
+              <a:t>Your stores, not ours — rename Costco, add the farmers market.</a:t>
+            </a:r>
+          </a:p>
+        </p:txBody>
+      </p:sp>
+      <p:sp>
+        <p:nvSpPr>
+          <p:cNvPr id="7" name="Rounded Rectangle 6"/>
+          <p:cNvSpPr/>
+          <p:nvPr/>
+        </p:nvSpPr>
+        <p:spPr>
+          <a:xfrm>
+            <a:off x="6327648" y="3136391"/>
+            <a:ext cx="5440680" cy="1325880"/>
+          </a:xfrm>
+          <a:prstGeom prst="roundRect">
+            <a:avLst/>
+          </a:prstGeom>
+          <a:solidFill>
+            <a:srgbClr val="141A2E"/>
+          </a:solidFill>
+          <a:ln w="6350">
+            <a:solidFill>
+              <a:srgbClr val="7C7FF2"/>
+            </a:solidFill>
+          </a:ln>
+          <a:effectLst/>
+        </p:spPr>
+        <p:style>
+          <a:lnRef idx="1">
+            <a:schemeClr val="accent1"/>
+          </a:lnRef>
+          <a:fillRef idx="3">
+            <a:schemeClr val="accent1"/>
+          </a:fillRef>
+          <a:effectRef idx="2">
+            <a:schemeClr val="accent1"/>
+          </a:effectRef>
+          <a:fontRef idx="minor">
+            <a:schemeClr val="lt1"/>
+          </a:fontRef>
+        </p:style>
+        <p:txBody>
+          <a:bodyPr wrap="square" lIns="201168" tIns="128016" rIns="201168" rtlCol="0" anchor="ctr"/>
+          <a:lstStyle/>
+          <a:p>
+            <a:pPr algn="ctr"/>
+            <a:r>
+              <a:rPr sz="1550" b="1">
+                <a:solidFill>
+                  <a:srgbClr val="7C7FF2"/>
+                </a:solidFill>
+                <a:latin typeface="Arial"/>
+              </a:rPr>
+              <a:t>Browser form-fill</a:t>
+            </a:r>
+          </a:p>
+          <a:p>
+            <a:pPr>
+              <a:spcBef>
+                <a:spcPts val="300"/>
+              </a:spcBef>
+            </a:pPr>
+            <a:r>
+              <a:rPr sz="1250">
+                <a:solidFill>
+                  <a:srgbClr val="F4F5FF"/>
+                </a:solidFill>
+                <a:latin typeface="Calibri"/>
+              </a:rPr>
+              <a:t>The last booking step, behind the step-up PIN tier.</a:t>
+            </a:r>
+          </a:p>
+        </p:txBody>
+      </p:sp>
+      <p:sp>
+        <p:nvSpPr>
+          <p:cNvPr id="8" name="Rounded Rectangle 7"/>
+          <p:cNvSpPr/>
+          <p:nvPr/>
+        </p:nvSpPr>
+        <p:spPr>
+          <a:xfrm>
+            <a:off x="566928" y="4718304"/>
+            <a:ext cx="5440680" cy="1325880"/>
+          </a:xfrm>
+          <a:prstGeom prst="roundRect">
+            <a:avLst/>
+          </a:prstGeom>
+          <a:solidFill>
+            <a:srgbClr val="141A2E"/>
+          </a:solidFill>
+          <a:ln w="6350">
+            <a:solidFill>
+              <a:srgbClr val="7C7FF2"/>
+            </a:solidFill>
+          </a:ln>
+          <a:effectLst/>
+        </p:spPr>
+        <p:style>
+          <a:lnRef idx="1">
+            <a:schemeClr val="accent1"/>
+          </a:lnRef>
+          <a:fillRef idx="3">
+            <a:schemeClr val="accent1"/>
+          </a:fillRef>
+          <a:effectRef idx="2">
+            <a:schemeClr val="accent1"/>
+          </a:effectRef>
+          <a:fontRef idx="minor">
+            <a:schemeClr val="lt1"/>
+          </a:fontRef>
+        </p:style>
+        <p:txBody>
+          <a:bodyPr wrap="square" lIns="201168" tIns="128016" rIns="201168" rtlCol="0" anchor="ctr"/>
+          <a:lstStyle/>
+          <a:p>
+            <a:pPr algn="ctr"/>
+            <a:r>
+              <a:rPr sz="1550" b="1">
+                <a:solidFill>
+                  <a:srgbClr val="7C7FF2"/>
+                </a:solidFill>
+                <a:latin typeface="Arial"/>
+              </a:rPr>
+              <a:t>Deeper proactivity</a:t>
+            </a:r>
+          </a:p>
+          <a:p>
+            <a:pPr>
+              <a:spcBef>
+                <a:spcPts val="300"/>
+              </a:spcBef>
+            </a:pPr>
+            <a:r>
+              <a:rPr sz="1250">
+                <a:solidFill>
+                  <a:srgbClr val="F4F5FF"/>
+                </a:solidFill>
+                <a:latin typeface="Calibri"/>
+              </a:rPr>
+              <a:t>Per-member personalized digests · event-driven triggers, not just the morning cron.</a:t>
+            </a:r>
+          </a:p>
+        </p:txBody>
+      </p:sp>
+      <p:sp>
+        <p:nvSpPr>
+          <p:cNvPr id="9" name="Rounded Rectangle 8"/>
+          <p:cNvSpPr/>
+          <p:nvPr/>
+        </p:nvSpPr>
+        <p:spPr>
+          <a:xfrm>
+            <a:off x="6327648" y="4718304"/>
+            <a:ext cx="5440680" cy="1325880"/>
+          </a:xfrm>
+          <a:prstGeom prst="roundRect">
+            <a:avLst/>
+          </a:prstGeom>
+          <a:solidFill>
+            <a:srgbClr val="141A2E"/>
+          </a:solidFill>
+          <a:ln w="6350">
+            <a:solidFill>
+              <a:srgbClr val="7C7FF2"/>
+            </a:solidFill>
+          </a:ln>
+          <a:effectLst/>
+        </p:spPr>
+        <p:style>
+          <a:lnRef idx="1">
+            <a:schemeClr val="accent1"/>
+          </a:lnRef>
+          <a:fillRef idx="3">
+            <a:schemeClr val="accent1"/>
+          </a:fillRef>
+          <a:effectRef idx="2">
+            <a:schemeClr val="accent1"/>
+          </a:effectRef>
+          <a:fontRef idx="minor">
+            <a:schemeClr val="lt1"/>
+          </a:fontRef>
+        </p:style>
+        <p:txBody>
+          <a:bodyPr wrap="square" lIns="201168" tIns="128016" rIns="201168" rtlCol="0" anchor="ctr"/>
+          <a:lstStyle/>
+          <a:p>
+            <a:pPr algn="ctr"/>
+            <a:r>
+              <a:rPr sz="1550" b="1">
+                <a:solidFill>
+                  <a:srgbClr val="7C7FF2"/>
+                </a:solidFill>
+                <a:latin typeface="Arial"/>
+              </a:rPr>
+              <a:t>Same approval gate</a:t>
+            </a:r>
+          </a:p>
+          <a:p>
+            <a:pPr>
+              <a:spcBef>
+                <a:spcPts val="300"/>
+              </a:spcBef>
+            </a:pPr>
+            <a:r>
+              <a:rPr sz="1250">
+                <a:solidFill>
+                  <a:srgbClr val="F4F5FF"/>
+                </a:solidFill>
+                <a:latin typeface="Calibri"/>
+              </a:rPr>
+              <a:t>Every new capability still stages a draft the adult approves.</a:t>
+            </a:r>
+          </a:p>
+        </p:txBody>
+      </p:sp>
+      <p:sp>
+        <p:nvSpPr>
+          <p:cNvPr id="10" name="TextBox 9"/>
           <p:cNvSpPr txBox="1"/>
           <p:nvPr/>
         </p:nvSpPr>
         <p:spPr>
           <a:xfrm>
-            <a:off x="548640" y="1554480"/>
-            <a:ext cx="5486400" cy="4937760"/>
+            <a:off x="548640" y="6355080"/>
+            <a:ext cx="11064240" cy="411480"/>
           </a:xfrm>
           <a:prstGeom prst="rect">
             <a:avLst/>
@@ -1722,185 +2157,15 @@
           </a:bodyPr>
           <a:lstStyle/>
           <a:p>
-            <a:pPr>
-              <a:spcAft>
-                <a:spcPts val="1400"/>
-              </a:spcAft>
-            </a:pPr>
-            <a:r>
-              <a:rPr sz="1700" b="1">
-                <a:solidFill>
-                  <a:srgbClr val="7C7FF2"/>
+            <a:pPr algn="ctr"/>
+            <a:r>
+              <a:rPr sz="1300" b="0">
+                <a:solidFill>
+                  <a:srgbClr val="9AA1C0"/>
                 </a:solidFill>
                 <a:latin typeface="Calibri"/>
               </a:rPr>
-              <a:t>One approval away. </a:t>
-            </a:r>
-            <a:r>
-              <a:rPr sz="1700" b="0">
-                <a:solidFill>
-                  <a:srgbClr val="F4F5FF"/>
-                </a:solidFill>
-                <a:latin typeface="Calibri"/>
-              </a:rPr>
-              <a:t>“I want paneer butter masala” → buy-unit ingredients → per-list Send → items in the family’s actual Fred Meyer cart.</a:t>
-            </a:r>
-          </a:p>
-          <a:p>
-            <a:pPr>
-              <a:spcAft>
-                <a:spcPts val="1400"/>
-              </a:spcAft>
-            </a:pPr>
-            <a:r>
-              <a:rPr sz="1700" b="1">
-                <a:solidFill>
-                  <a:srgbClr val="F2B84B"/>
-                </a:solidFill>
-                <a:latin typeface="Calibri"/>
-              </a:rPr>
-              <a:t>Pick-or-decline matching. </a:t>
-            </a:r>
-            <a:r>
-              <a:rPr sz="1700" b="0">
-                <a:solidFill>
-                  <a:srgbClr val="F4F5FF"/>
-                </a:solidFill>
-                <a:latin typeface="Calibri"/>
-              </a:rPr>
-              <a:t>Kroger search returns frying pans for “paneer” — the model must choose from the store’s real candidates or say no; declines get one second look.</a:t>
-            </a:r>
-          </a:p>
-          <a:p>
-            <a:pPr>
-              <a:spcAft>
-                <a:spcPts val="1400"/>
-              </a:spcAft>
-            </a:pPr>
-            <a:r>
-              <a:rPr sz="1700" b="1">
-                <a:solidFill>
-                  <a:srgbClr val="7C7FF2"/>
-                </a:solidFill>
-                <a:latin typeface="Calibri"/>
-              </a:rPr>
-              <a:t>Honest per-item reasons. </a:t>
-            </a:r>
-            <a:r>
-              <a:rPr sz="1700" b="0">
-                <a:solidFill>
-                  <a:srgbClr val="F4F5FF"/>
-                </a:solidFill>
-                <a:latin typeface="Calibri"/>
-              </a:rPr>
-              <a:t>no match at this store ≠ couldn’t confidently match ≠ search failed — unmatched items stay on the list.</a:t>
-            </a:r>
-          </a:p>
-          <a:p>
-            <a:pPr>
-              <a:spcAft>
-                <a:spcPts val="1400"/>
-              </a:spcAft>
-            </a:pPr>
-            <a:r>
-              <a:rPr sz="1700" b="1">
-                <a:solidFill>
-                  <a:srgbClr val="F2B84B"/>
-                </a:solidFill>
-                <a:latin typeface="Calibri"/>
-              </a:rPr>
-              <a:t>Still no payment tool. </a:t>
-            </a:r>
-            <a:r>
-              <a:rPr sz="1700" b="0">
-                <a:solidFill>
-                  <a:srgbClr val="F4F5FF"/>
-                </a:solidFill>
-                <a:latin typeface="Calibri"/>
-              </a:rPr>
-              <a:t>The public API has no checkout endpoint — the parent pays in Kroger’s own app. Setup: docs/kroger-setup.md.</a:t>
-            </a:r>
-          </a:p>
-        </p:txBody>
-      </p:sp>
-      <p:pic>
-        <p:nvPicPr>
-          <p:cNvPr id="5" name="Picture 4" descr="Screenshot 2026-07-06 142153.png"/>
-          <p:cNvPicPr>
-            <a:picLocks noChangeAspect="1"/>
-          </p:cNvPicPr>
-          <p:nvPr/>
-        </p:nvPicPr>
-        <p:blipFill>
-          <a:blip r:embed="rId2"/>
-          <a:stretch>
-            <a:fillRect/>
-          </a:stretch>
-        </p:blipFill>
-        <p:spPr>
-          <a:xfrm>
-            <a:off x="7319304" y="1371600"/>
-            <a:ext cx="3375071" cy="2377440"/>
-          </a:xfrm>
-          <a:prstGeom prst="rect">
-            <a:avLst/>
-          </a:prstGeom>
-        </p:spPr>
-      </p:pic>
-      <p:pic>
-        <p:nvPicPr>
-          <p:cNvPr id="6" name="Picture 5" descr="Screenshot 2026-07-06 142309.png"/>
-          <p:cNvPicPr>
-            <a:picLocks noChangeAspect="1"/>
-          </p:cNvPicPr>
-          <p:nvPr/>
-        </p:nvPicPr>
-        <p:blipFill>
-          <a:blip r:embed="rId3"/>
-          <a:stretch>
-            <a:fillRect/>
-          </a:stretch>
-        </p:blipFill>
-        <p:spPr>
-          <a:xfrm>
-            <a:off x="7116824" y="3913632"/>
-            <a:ext cx="3780030" cy="2377440"/>
-          </a:xfrm>
-          <a:prstGeom prst="rect">
-            <a:avLst/>
-          </a:prstGeom>
-        </p:spPr>
-      </p:pic>
-      <p:sp>
-        <p:nvSpPr>
-          <p:cNvPr id="7" name="TextBox 6"/>
-          <p:cNvSpPr txBox="1"/>
-          <p:nvPr/>
-        </p:nvSpPr>
-        <p:spPr>
-          <a:xfrm>
-            <a:off x="548640" y="6400800"/>
-            <a:ext cx="11064240" cy="365760"/>
-          </a:xfrm>
-          <a:prstGeom prst="rect">
-            <a:avLst/>
-          </a:prstGeom>
-          <a:noFill/>
-        </p:spPr>
-        <p:txBody>
-          <a:bodyPr wrap="square">
-            <a:spAutoFit/>
-          </a:bodyPr>
-          <a:lstStyle/>
-          <a:p>
-            <a:r>
-              <a:rPr sz="1100" b="0">
-                <a:solidFill>
-                  <a:srgbClr val="9AA1C0"/>
-                </a:solidFill>
-                <a:latin typeface="Calibri"/>
-              </a:rPr>
-              <a:t>Owner-verified live 2026-07-06 · the hosted demo runs the submission-freeze build — this loop ships on the repo’s default branch with tests + setup guide</a:t>
+              <a:t>Family-Hub · AGPL open source · github.com/msampath/fam-hub</a:t>
             </a:r>
           </a:p>
         </p:txBody>
@@ -3824,6 +4089,305 @@
 </file>
 
 <file path=ppt/slides/slide7.xml><?xml version="1.0" encoding="utf-8"?>
+<p:sld xmlns:a="http://schemas.openxmlformats.org/drawingml/2006/main" xmlns:p="http://schemas.openxmlformats.org/presentationml/2006/main" xmlns:r="http://schemas.openxmlformats.org/officeDocument/2006/relationships">
+  <p:cSld>
+    <p:bg>
+      <p:bgPr>
+        <a:solidFill>
+          <a:srgbClr val="0B0F1A"/>
+        </a:solidFill>
+        <a:effectLst/>
+      </p:bgPr>
+    </p:bg>
+    <p:spTree>
+      <p:nvGrpSpPr>
+        <p:cNvPr id="1" name=""/>
+        <p:cNvGrpSpPr/>
+        <p:nvPr/>
+      </p:nvGrpSpPr>
+      <p:grpSpPr/>
+      <p:sp>
+        <p:nvSpPr>
+          <p:cNvPr id="2" name="TextBox 1"/>
+          <p:cNvSpPr txBox="1"/>
+          <p:nvPr/>
+        </p:nvSpPr>
+        <p:spPr>
+          <a:xfrm>
+            <a:off x="548640" y="91440"/>
+            <a:ext cx="9144000" cy="274320"/>
+          </a:xfrm>
+          <a:prstGeom prst="rect">
+            <a:avLst/>
+          </a:prstGeom>
+          <a:noFill/>
+        </p:spPr>
+        <p:txBody>
+          <a:bodyPr wrap="square">
+            <a:spAutoFit/>
+          </a:bodyPr>
+          <a:lstStyle/>
+          <a:p>
+            <a:r>
+              <a:rPr sz="1200" b="1">
+                <a:solidFill>
+                  <a:srgbClr val="7C7FF2"/>
+                </a:solidFill>
+                <a:latin typeface="Arial"/>
+              </a:rPr>
+              <a:t>ADDED IN-WINDOW</a:t>
+            </a:r>
+          </a:p>
+        </p:txBody>
+      </p:sp>
+      <p:sp>
+        <p:nvSpPr>
+          <p:cNvPr id="3" name="TextBox 2"/>
+          <p:cNvSpPr txBox="1"/>
+          <p:nvPr/>
+        </p:nvSpPr>
+        <p:spPr>
+          <a:xfrm>
+            <a:off x="548640" y="457200"/>
+            <a:ext cx="11064240" cy="731520"/>
+          </a:xfrm>
+          <a:prstGeom prst="rect">
+            <a:avLst/>
+          </a:prstGeom>
+          <a:noFill/>
+        </p:spPr>
+        <p:txBody>
+          <a:bodyPr wrap="square">
+            <a:spAutoFit/>
+          </a:bodyPr>
+          <a:lstStyle/>
+          <a:p>
+            <a:r>
+              <a:rPr sz="3400" b="1">
+                <a:solidFill>
+                  <a:srgbClr val="F4F5FF"/>
+                </a:solidFill>
+                <a:latin typeface="Arial"/>
+              </a:rPr>
+              <a:t>Intent → a planned, provisioned week</a:t>
+            </a:r>
+          </a:p>
+        </p:txBody>
+      </p:sp>
+      <p:sp>
+        <p:nvSpPr>
+          <p:cNvPr id="4" name="TextBox 3"/>
+          <p:cNvSpPr txBox="1"/>
+          <p:nvPr/>
+        </p:nvSpPr>
+        <p:spPr>
+          <a:xfrm>
+            <a:off x="548640" y="1554480"/>
+            <a:ext cx="5486400" cy="4937760"/>
+          </a:xfrm>
+          <a:prstGeom prst="rect">
+            <a:avLst/>
+          </a:prstGeom>
+          <a:noFill/>
+        </p:spPr>
+        <p:txBody>
+          <a:bodyPr wrap="square">
+            <a:spAutoFit/>
+          </a:bodyPr>
+          <a:lstStyle/>
+          <a:p>
+            <a:pPr>
+              <a:spcAft>
+                <a:spcPts val="1400"/>
+              </a:spcAft>
+            </a:pPr>
+            <a:r>
+              <a:rPr sz="1700" b="1">
+                <a:solidFill>
+                  <a:srgbClr val="7C7FF2"/>
+                </a:solidFill>
+                <a:latin typeface="Calibri"/>
+              </a:rPr>
+              <a:t>Plan → provision. </a:t>
+            </a:r>
+            <a:r>
+              <a:rPr sz="1700" b="0">
+                <a:solidFill>
+                  <a:srgbClr val="F4F5FF"/>
+                </a:solidFill>
+                <a:latin typeface="Calibri"/>
+              </a:rPr>
+              <a:t>“Plan next week’s lunches…” → the week on a Today strip + ONE consolidated, diet-aware, store-routed list → per-list Send → the family’s real Fred Meyer cart.</a:t>
+            </a:r>
+          </a:p>
+          <a:p>
+            <a:pPr>
+              <a:spcAft>
+                <a:spcPts val="1400"/>
+              </a:spcAft>
+            </a:pPr>
+            <a:r>
+              <a:rPr sz="1700" b="1">
+                <a:solidFill>
+                  <a:srgbClr val="F2B84B"/>
+                </a:solidFill>
+                <a:latin typeface="Calibri"/>
+              </a:rPr>
+              <a:t>Pick-or-decline matching. </a:t>
+            </a:r>
+            <a:r>
+              <a:rPr sz="1700" b="0">
+                <a:solidFill>
+                  <a:srgbClr val="F4F5FF"/>
+                </a:solidFill>
+                <a:latin typeface="Calibri"/>
+              </a:rPr>
+              <a:t>Kroger search returns frying pans for “paneer” — the model must choose from the store’s real candidates or say no; declines get one second look.</a:t>
+            </a:r>
+          </a:p>
+          <a:p>
+            <a:pPr>
+              <a:spcAft>
+                <a:spcPts val="1400"/>
+              </a:spcAft>
+            </a:pPr>
+            <a:r>
+              <a:rPr sz="1700" b="1">
+                <a:solidFill>
+                  <a:srgbClr val="7C7FF2"/>
+                </a:solidFill>
+                <a:latin typeface="Calibri"/>
+              </a:rPr>
+              <a:t>Honest per-item reasons. </a:t>
+            </a:r>
+            <a:r>
+              <a:rPr sz="1700" b="0">
+                <a:solidFill>
+                  <a:srgbClr val="F4F5FF"/>
+                </a:solidFill>
+                <a:latin typeface="Calibri"/>
+              </a:rPr>
+              <a:t>no match at this store ≠ couldn’t confidently match ≠ search failed — unmatched items stay on the list.</a:t>
+            </a:r>
+          </a:p>
+          <a:p>
+            <a:pPr>
+              <a:spcAft>
+                <a:spcPts val="1400"/>
+              </a:spcAft>
+            </a:pPr>
+            <a:r>
+              <a:rPr sz="1700" b="1">
+                <a:solidFill>
+                  <a:srgbClr val="F2B84B"/>
+                </a:solidFill>
+                <a:latin typeface="Calibri"/>
+              </a:rPr>
+              <a:t>Still no payment tool. </a:t>
+            </a:r>
+            <a:r>
+              <a:rPr sz="1700" b="0">
+                <a:solidFill>
+                  <a:srgbClr val="F4F5FF"/>
+                </a:solidFill>
+                <a:latin typeface="Calibri"/>
+              </a:rPr>
+              <a:t>The public API has no checkout endpoint — the parent pays in Kroger’s own app. Setup: docs/kroger-setup.md.</a:t>
+            </a:r>
+          </a:p>
+        </p:txBody>
+      </p:sp>
+      <p:pic>
+        <p:nvPicPr>
+          <p:cNvPr id="5" name="Picture 4" descr="Screenshot 2026-07-06 142153.png"/>
+          <p:cNvPicPr>
+            <a:picLocks noChangeAspect="1"/>
+          </p:cNvPicPr>
+          <p:nvPr/>
+        </p:nvPicPr>
+        <p:blipFill>
+          <a:blip r:embed="rId2"/>
+          <a:stretch>
+            <a:fillRect/>
+          </a:stretch>
+        </p:blipFill>
+        <p:spPr>
+          <a:xfrm>
+            <a:off x="7319304" y="1371600"/>
+            <a:ext cx="3375071" cy="2377440"/>
+          </a:xfrm>
+          <a:prstGeom prst="rect">
+            <a:avLst/>
+          </a:prstGeom>
+        </p:spPr>
+      </p:pic>
+      <p:pic>
+        <p:nvPicPr>
+          <p:cNvPr id="6" name="Picture 5" descr="Screenshot 2026-07-06 142309.png"/>
+          <p:cNvPicPr>
+            <a:picLocks noChangeAspect="1"/>
+          </p:cNvPicPr>
+          <p:nvPr/>
+        </p:nvPicPr>
+        <p:blipFill>
+          <a:blip r:embed="rId3"/>
+          <a:stretch>
+            <a:fillRect/>
+          </a:stretch>
+        </p:blipFill>
+        <p:spPr>
+          <a:xfrm>
+            <a:off x="7116824" y="3913632"/>
+            <a:ext cx="3780030" cy="2377440"/>
+          </a:xfrm>
+          <a:prstGeom prst="rect">
+            <a:avLst/>
+          </a:prstGeom>
+        </p:spPr>
+      </p:pic>
+      <p:sp>
+        <p:nvSpPr>
+          <p:cNvPr id="7" name="TextBox 6"/>
+          <p:cNvSpPr txBox="1"/>
+          <p:nvPr/>
+        </p:nvSpPr>
+        <p:spPr>
+          <a:xfrm>
+            <a:off x="548640" y="6400800"/>
+            <a:ext cx="11064240" cy="365760"/>
+          </a:xfrm>
+          <a:prstGeom prst="rect">
+            <a:avLst/>
+          </a:prstGeom>
+          <a:noFill/>
+        </p:spPr>
+        <p:txBody>
+          <a:bodyPr wrap="square">
+            <a:spAutoFit/>
+          </a:bodyPr>
+          <a:lstStyle/>
+          <a:p>
+            <a:r>
+              <a:rPr sz="1100" b="0">
+                <a:solidFill>
+                  <a:srgbClr val="9AA1C0"/>
+                </a:solidFill>
+                <a:latin typeface="Calibri"/>
+              </a:rPr>
+              <a:t>Owner-verified live 2026-07-06 · the hosted demo runs the submission-freeze build — this loop ships on the repo’s default branch with tests + setup guide</a:t>
+            </a:r>
+          </a:p>
+        </p:txBody>
+      </p:sp>
+    </p:spTree>
+  </p:cSld>
+  <p:clrMapOvr>
+    <a:masterClrMapping/>
+  </p:clrMapOvr>
+</p:sld>
+</file>
+
+<file path=ppt/slides/slide8.xml><?xml version="1.0" encoding="utf-8"?>
 <p:sld xmlns:a="http://schemas.openxmlformats.org/drawingml/2006/main" xmlns:r="http://schemas.openxmlformats.org/officeDocument/2006/relationships" xmlns:p="http://schemas.openxmlformats.org/presentationml/2006/main">
   <p:cSld name="Slide 7">
     <p:bg>
@@ -4332,7 +4896,7 @@
                 <a:ea typeface="Calibri" pitchFamily="34" charset="-122"/>
                 <a:cs typeface="Calibri" pitchFamily="34" charset="-120"/>
               </a:rPr>
-              <a:t>1,191 frontend tests · 37 agent tests · deployable three ways: Cloud Run, docker compose, Raspberry Pi</a:t>
+              <a:t>1,200+ frontend tests · 39 agent tests · deployable three ways: Cloud Run, docker compose, Raspberry Pi</a:t>
             </a:r>
             <a:endParaRPr lang="en-US" sz="1500" dirty="0"/>
           </a:p>
@@ -4346,7 +4910,7 @@
 </p:sld>
 </file>
 
-<file path=ppt/slides/slide8.xml><?xml version="1.0" encoding="utf-8"?>
+<file path=ppt/slides/slide9.xml><?xml version="1.0" encoding="utf-8"?>
 <p:sld xmlns:a="http://schemas.openxmlformats.org/drawingml/2006/main" xmlns:r="http://schemas.openxmlformats.org/officeDocument/2006/relationships" xmlns:p="http://schemas.openxmlformats.org/presentationml/2006/main">
   <p:cSld name="Slide 8">
     <p:bg>
@@ -4617,570 +5181,6 @@
               <a:ea typeface="Calibri" pitchFamily="34" charset="-122"/>
               <a:cs typeface="Calibri" pitchFamily="34" charset="-120"/>
             </a:endParaRPr>
-          </a:p>
-        </p:txBody>
-      </p:sp>
-    </p:spTree>
-  </p:cSld>
-  <p:clrMapOvr>
-    <a:masterClrMapping/>
-  </p:clrMapOvr>
-</p:sld>
-</file>
-
-<file path=ppt/slides/slide9.xml><?xml version="1.0" encoding="utf-8"?>
-<p:sld xmlns:a="http://schemas.openxmlformats.org/drawingml/2006/main" xmlns:r="http://schemas.openxmlformats.org/officeDocument/2006/relationships" xmlns:p="http://schemas.openxmlformats.org/presentationml/2006/main">
-  <p:cSld>
-    <p:bg>
-      <p:bgPr>
-        <a:solidFill>
-          <a:srgbClr val="0B0F1A"/>
-        </a:solidFill>
-        <a:effectLst/>
-      </p:bgPr>
-    </p:bg>
-    <p:spTree>
-      <p:nvGrpSpPr>
-        <p:cNvPr id="1" name=""/>
-        <p:cNvGrpSpPr/>
-        <p:nvPr/>
-      </p:nvGrpSpPr>
-      <p:grpSpPr>
-        <a:xfrm>
-          <a:off x="0" y="0"/>
-          <a:ext cx="0" cy="0"/>
-          <a:chOff x="0" y="0"/>
-          <a:chExt cx="0" cy="0"/>
-        </a:xfrm>
-      </p:grpSpPr>
-      <p:sp>
-        <p:nvSpPr>
-          <p:cNvPr id="2" name="TextBox 1"/>
-          <p:cNvSpPr txBox="1"/>
-          <p:nvPr/>
-        </p:nvSpPr>
-        <p:spPr>
-          <a:xfrm>
-            <a:off x="566928" y="109728"/>
-            <a:ext cx="9144000" cy="320040"/>
-          </a:xfrm>
-          <a:prstGeom prst="rect">
-            <a:avLst/>
-          </a:prstGeom>
-          <a:noFill/>
-        </p:spPr>
-        <p:txBody>
-          <a:bodyPr wrap="square">
-            <a:spAutoFit/>
-          </a:bodyPr>
-          <a:lstStyle/>
-          <a:p>
-            <a:pPr algn="l"/>
-            <a:r>
-              <a:rPr sz="1200" b="1">
-                <a:solidFill>
-                  <a:srgbClr val="7C7FF2"/>
-                </a:solidFill>
-                <a:latin typeface="Arial"/>
-              </a:rPr>
-              <a:t>WHAT’S NEXT</a:t>
-            </a:r>
-          </a:p>
-        </p:txBody>
-      </p:sp>
-      <p:sp>
-        <p:nvSpPr>
-          <p:cNvPr id="3" name="TextBox 2"/>
-          <p:cNvSpPr txBox="1"/>
-          <p:nvPr/>
-        </p:nvSpPr>
-        <p:spPr>
-          <a:xfrm>
-            <a:off x="548640" y="411480"/>
-            <a:ext cx="11064240" cy="777240"/>
-          </a:xfrm>
-          <a:prstGeom prst="rect">
-            <a:avLst/>
-          </a:prstGeom>
-          <a:noFill/>
-        </p:spPr>
-        <p:txBody>
-          <a:bodyPr wrap="square">
-            <a:spAutoFit/>
-          </a:bodyPr>
-          <a:lstStyle/>
-          <a:p>
-            <a:pPr algn="l"/>
-            <a:r>
-              <a:rPr sz="3400" b="1">
-                <a:solidFill>
-                  <a:srgbClr val="F4F5FF"/>
-                </a:solidFill>
-                <a:latin typeface="Arial"/>
-              </a:rPr>
-              <a:t>This week’s roadmap — same safety spine</a:t>
-            </a:r>
-          </a:p>
-        </p:txBody>
-      </p:sp>
-      <p:sp>
-        <p:nvSpPr>
-          <p:cNvPr id="4" name="Rounded Rectangle 3"/>
-          <p:cNvSpPr/>
-          <p:nvPr/>
-        </p:nvSpPr>
-        <p:spPr>
-          <a:xfrm>
-            <a:off x="566928" y="1554480"/>
-            <a:ext cx="5440680" cy="1325880"/>
-          </a:xfrm>
-          <a:prstGeom prst="roundRect">
-            <a:avLst/>
-          </a:prstGeom>
-          <a:solidFill>
-            <a:srgbClr val="141A2E"/>
-          </a:solidFill>
-          <a:ln w="6350">
-            <a:solidFill>
-              <a:srgbClr val="7C7FF2"/>
-            </a:solidFill>
-          </a:ln>
-          <a:effectLst/>
-        </p:spPr>
-        <p:style>
-          <a:lnRef idx="1">
-            <a:schemeClr val="accent1"/>
-          </a:lnRef>
-          <a:fillRef idx="3">
-            <a:schemeClr val="accent1"/>
-          </a:fillRef>
-          <a:effectRef idx="2">
-            <a:schemeClr val="accent1"/>
-          </a:effectRef>
-          <a:fontRef idx="minor">
-            <a:schemeClr val="lt1"/>
-          </a:fontRef>
-        </p:style>
-        <p:txBody>
-          <a:bodyPr wrap="square" lIns="201168" tIns="128016" rIns="201168" rtlCol="0" anchor="ctr"/>
-          <a:lstStyle/>
-          <a:p>
-            <a:pPr algn="ctr"/>
-            <a:r>
-              <a:rPr sz="1550" b="1">
-                <a:solidFill>
-                  <a:srgbClr val="F2B84B"/>
-                </a:solidFill>
-                <a:latin typeface="Arial"/>
-              </a:rPr>
-              <a:t>Instacart adapter (next)</a:t>
-            </a:r>
-          </a:p>
-          <a:p>
-            <a:pPr>
-              <a:spcBef>
-                <a:spcPts val="300"/>
-              </a:spcBef>
-            </a:pPr>
-            <a:r>
-              <a:rPr sz="1250">
-                <a:solidFill>
-                  <a:srgbClr val="F4F5FF"/>
-                </a:solidFill>
-                <a:latin typeface="Calibri"/>
-              </a:rPr>
-              <a:t>Kroger loop SHIPPED in-window — next retailer is a second connection card: shoppable lists across 1,500+ banners (covers Costco)</a:t>
-            </a:r>
-          </a:p>
-        </p:txBody>
-      </p:sp>
-      <p:sp>
-        <p:nvSpPr>
-          <p:cNvPr id="5" name="Rounded Rectangle 4"/>
-          <p:cNvSpPr/>
-          <p:nvPr/>
-        </p:nvSpPr>
-        <p:spPr>
-          <a:xfrm>
-            <a:off x="6327648" y="1554480"/>
-            <a:ext cx="5440680" cy="1325880"/>
-          </a:xfrm>
-          <a:prstGeom prst="roundRect">
-            <a:avLst/>
-          </a:prstGeom>
-          <a:solidFill>
-            <a:srgbClr val="141A2E"/>
-          </a:solidFill>
-          <a:ln w="6350">
-            <a:solidFill>
-              <a:srgbClr val="7C7FF2"/>
-            </a:solidFill>
-          </a:ln>
-          <a:effectLst/>
-        </p:spPr>
-        <p:style>
-          <a:lnRef idx="1">
-            <a:schemeClr val="accent1"/>
-          </a:lnRef>
-          <a:fillRef idx="3">
-            <a:schemeClr val="accent1"/>
-          </a:fillRef>
-          <a:effectRef idx="2">
-            <a:schemeClr val="accent1"/>
-          </a:effectRef>
-          <a:fontRef idx="minor">
-            <a:schemeClr val="lt1"/>
-          </a:fontRef>
-        </p:style>
-        <p:txBody>
-          <a:bodyPr wrap="square" lIns="201168" tIns="128016" rIns="201168" rtlCol="0" anchor="ctr"/>
-          <a:lstStyle/>
-          <a:p>
-            <a:pPr algn="ctr"/>
-            <a:r>
-              <a:rPr sz="1550" b="1">
-                <a:solidFill>
-                  <a:srgbClr val="F2B84B"/>
-                </a:solidFill>
-                <a:latin typeface="Arial"/>
-              </a:rPr>
-              <a:t>$0 private mode</a:t>
-            </a:r>
-          </a:p>
-          <a:p>
-            <a:pPr>
-              <a:spcBef>
-                <a:spcPts val="300"/>
-              </a:spcBef>
-            </a:pPr>
-            <a:r>
-              <a:rPr sz="1250">
-                <a:solidFill>
-                  <a:srgbClr val="F4F5FF"/>
-                </a:solidFill>
-                <a:latin typeface="Calibri"/>
-              </a:rPr>
-              <a:t>gpt-oss:20b running locally on the home box — no cloud, no bill. Eval-gated before it ever serves the family.</a:t>
-            </a:r>
-          </a:p>
-        </p:txBody>
-      </p:sp>
-      <p:sp>
-        <p:nvSpPr>
-          <p:cNvPr id="6" name="Rounded Rectangle 5"/>
-          <p:cNvSpPr/>
-          <p:nvPr/>
-        </p:nvSpPr>
-        <p:spPr>
-          <a:xfrm>
-            <a:off x="566928" y="3136391"/>
-            <a:ext cx="5440680" cy="1325880"/>
-          </a:xfrm>
-          <a:prstGeom prst="roundRect">
-            <a:avLst/>
-          </a:prstGeom>
-          <a:solidFill>
-            <a:srgbClr val="141A2E"/>
-          </a:solidFill>
-          <a:ln w="6350">
-            <a:solidFill>
-              <a:srgbClr val="7C7FF2"/>
-            </a:solidFill>
-          </a:ln>
-          <a:effectLst/>
-        </p:spPr>
-        <p:style>
-          <a:lnRef idx="1">
-            <a:schemeClr val="accent1"/>
-          </a:lnRef>
-          <a:fillRef idx="3">
-            <a:schemeClr val="accent1"/>
-          </a:fillRef>
-          <a:effectRef idx="2">
-            <a:schemeClr val="accent1"/>
-          </a:effectRef>
-          <a:fontRef idx="minor">
-            <a:schemeClr val="lt1"/>
-          </a:fontRef>
-        </p:style>
-        <p:txBody>
-          <a:bodyPr wrap="square" lIns="201168" tIns="128016" rIns="201168" rtlCol="0" anchor="ctr"/>
-          <a:lstStyle/>
-          <a:p>
-            <a:pPr algn="ctr"/>
-            <a:r>
-              <a:rPr sz="1550" b="1">
-                <a:solidFill>
-                  <a:srgbClr val="7C7FF2"/>
-                </a:solidFill>
-                <a:latin typeface="Arial"/>
-              </a:rPr>
-              <a:t>Household-defined store lists</a:t>
-            </a:r>
-          </a:p>
-          <a:p>
-            <a:pPr>
-              <a:spcBef>
-                <a:spcPts val="300"/>
-              </a:spcBef>
-            </a:pPr>
-            <a:r>
-              <a:rPr sz="1250">
-                <a:solidFill>
-                  <a:srgbClr val="F4F5FF"/>
-                </a:solidFill>
-                <a:latin typeface="Calibri"/>
-              </a:rPr>
-              <a:t>Your stores, not ours — rename Costco, add the farmers market.</a:t>
-            </a:r>
-          </a:p>
-        </p:txBody>
-      </p:sp>
-      <p:sp>
-        <p:nvSpPr>
-          <p:cNvPr id="7" name="Rounded Rectangle 6"/>
-          <p:cNvSpPr/>
-          <p:nvPr/>
-        </p:nvSpPr>
-        <p:spPr>
-          <a:xfrm>
-            <a:off x="6327648" y="3136391"/>
-            <a:ext cx="5440680" cy="1325880"/>
-          </a:xfrm>
-          <a:prstGeom prst="roundRect">
-            <a:avLst/>
-          </a:prstGeom>
-          <a:solidFill>
-            <a:srgbClr val="141A2E"/>
-          </a:solidFill>
-          <a:ln w="6350">
-            <a:solidFill>
-              <a:srgbClr val="7C7FF2"/>
-            </a:solidFill>
-          </a:ln>
-          <a:effectLst/>
-        </p:spPr>
-        <p:style>
-          <a:lnRef idx="1">
-            <a:schemeClr val="accent1"/>
-          </a:lnRef>
-          <a:fillRef idx="3">
-            <a:schemeClr val="accent1"/>
-          </a:fillRef>
-          <a:effectRef idx="2">
-            <a:schemeClr val="accent1"/>
-          </a:effectRef>
-          <a:fontRef idx="minor">
-            <a:schemeClr val="lt1"/>
-          </a:fontRef>
-        </p:style>
-        <p:txBody>
-          <a:bodyPr wrap="square" lIns="201168" tIns="128016" rIns="201168" rtlCol="0" anchor="ctr"/>
-          <a:lstStyle/>
-          <a:p>
-            <a:pPr algn="ctr"/>
-            <a:r>
-              <a:rPr sz="1550" b="1">
-                <a:solidFill>
-                  <a:srgbClr val="7C7FF2"/>
-                </a:solidFill>
-                <a:latin typeface="Arial"/>
-              </a:rPr>
-              <a:t>Browser form-fill</a:t>
-            </a:r>
-          </a:p>
-          <a:p>
-            <a:pPr>
-              <a:spcBef>
-                <a:spcPts val="300"/>
-              </a:spcBef>
-            </a:pPr>
-            <a:r>
-              <a:rPr sz="1250">
-                <a:solidFill>
-                  <a:srgbClr val="F4F5FF"/>
-                </a:solidFill>
-                <a:latin typeface="Calibri"/>
-              </a:rPr>
-              <a:t>The last booking step, behind the step-up PIN tier.</a:t>
-            </a:r>
-          </a:p>
-        </p:txBody>
-      </p:sp>
-      <p:sp>
-        <p:nvSpPr>
-          <p:cNvPr id="8" name="Rounded Rectangle 7"/>
-          <p:cNvSpPr/>
-          <p:nvPr/>
-        </p:nvSpPr>
-        <p:spPr>
-          <a:xfrm>
-            <a:off x="566928" y="4718304"/>
-            <a:ext cx="5440680" cy="1325880"/>
-          </a:xfrm>
-          <a:prstGeom prst="roundRect">
-            <a:avLst/>
-          </a:prstGeom>
-          <a:solidFill>
-            <a:srgbClr val="141A2E"/>
-          </a:solidFill>
-          <a:ln w="6350">
-            <a:solidFill>
-              <a:srgbClr val="7C7FF2"/>
-            </a:solidFill>
-          </a:ln>
-          <a:effectLst/>
-        </p:spPr>
-        <p:style>
-          <a:lnRef idx="1">
-            <a:schemeClr val="accent1"/>
-          </a:lnRef>
-          <a:fillRef idx="3">
-            <a:schemeClr val="accent1"/>
-          </a:fillRef>
-          <a:effectRef idx="2">
-            <a:schemeClr val="accent1"/>
-          </a:effectRef>
-          <a:fontRef idx="minor">
-            <a:schemeClr val="lt1"/>
-          </a:fontRef>
-        </p:style>
-        <p:txBody>
-          <a:bodyPr wrap="square" lIns="201168" tIns="128016" rIns="201168" rtlCol="0" anchor="ctr"/>
-          <a:lstStyle/>
-          <a:p>
-            <a:pPr algn="ctr"/>
-            <a:r>
-              <a:rPr sz="1550" b="1">
-                <a:solidFill>
-                  <a:srgbClr val="7C7FF2"/>
-                </a:solidFill>
-                <a:latin typeface="Arial"/>
-              </a:rPr>
-              <a:t>Deeper proactivity</a:t>
-            </a:r>
-          </a:p>
-          <a:p>
-            <a:pPr>
-              <a:spcBef>
-                <a:spcPts val="300"/>
-              </a:spcBef>
-            </a:pPr>
-            <a:r>
-              <a:rPr sz="1250">
-                <a:solidFill>
-                  <a:srgbClr val="F4F5FF"/>
-                </a:solidFill>
-                <a:latin typeface="Calibri"/>
-              </a:rPr>
-              <a:t>Per-member personalized digests · event-driven triggers, not just the morning cron.</a:t>
-            </a:r>
-          </a:p>
-        </p:txBody>
-      </p:sp>
-      <p:sp>
-        <p:nvSpPr>
-          <p:cNvPr id="9" name="Rounded Rectangle 8"/>
-          <p:cNvSpPr/>
-          <p:nvPr/>
-        </p:nvSpPr>
-        <p:spPr>
-          <a:xfrm>
-            <a:off x="6327648" y="4718304"/>
-            <a:ext cx="5440680" cy="1325880"/>
-          </a:xfrm>
-          <a:prstGeom prst="roundRect">
-            <a:avLst/>
-          </a:prstGeom>
-          <a:solidFill>
-            <a:srgbClr val="141A2E"/>
-          </a:solidFill>
-          <a:ln w="6350">
-            <a:solidFill>
-              <a:srgbClr val="7C7FF2"/>
-            </a:solidFill>
-          </a:ln>
-          <a:effectLst/>
-        </p:spPr>
-        <p:style>
-          <a:lnRef idx="1">
-            <a:schemeClr val="accent1"/>
-          </a:lnRef>
-          <a:fillRef idx="3">
-            <a:schemeClr val="accent1"/>
-          </a:fillRef>
-          <a:effectRef idx="2">
-            <a:schemeClr val="accent1"/>
-          </a:effectRef>
-          <a:fontRef idx="minor">
-            <a:schemeClr val="lt1"/>
-          </a:fontRef>
-        </p:style>
-        <p:txBody>
-          <a:bodyPr wrap="square" lIns="201168" tIns="128016" rIns="201168" rtlCol="0" anchor="ctr"/>
-          <a:lstStyle/>
-          <a:p>
-            <a:pPr algn="ctr"/>
-            <a:r>
-              <a:rPr sz="1550" b="1">
-                <a:solidFill>
-                  <a:srgbClr val="7C7FF2"/>
-                </a:solidFill>
-                <a:latin typeface="Arial"/>
-              </a:rPr>
-              <a:t>Same approval gate</a:t>
-            </a:r>
-          </a:p>
-          <a:p>
-            <a:pPr>
-              <a:spcBef>
-                <a:spcPts val="300"/>
-              </a:spcBef>
-            </a:pPr>
-            <a:r>
-              <a:rPr sz="1250">
-                <a:solidFill>
-                  <a:srgbClr val="F4F5FF"/>
-                </a:solidFill>
-                <a:latin typeface="Calibri"/>
-              </a:rPr>
-              <a:t>Every new capability still stages a draft the adult approves.</a:t>
-            </a:r>
-          </a:p>
-        </p:txBody>
-      </p:sp>
-      <p:sp>
-        <p:nvSpPr>
-          <p:cNvPr id="10" name="TextBox 9"/>
-          <p:cNvSpPr txBox="1"/>
-          <p:nvPr/>
-        </p:nvSpPr>
-        <p:spPr>
-          <a:xfrm>
-            <a:off x="548640" y="6355080"/>
-            <a:ext cx="11064240" cy="411480"/>
-          </a:xfrm>
-          <a:prstGeom prst="rect">
-            <a:avLst/>
-          </a:prstGeom>
-          <a:noFill/>
-        </p:spPr>
-        <p:txBody>
-          <a:bodyPr wrap="square">
-            <a:spAutoFit/>
-          </a:bodyPr>
-          <a:lstStyle/>
-          <a:p>
-            <a:pPr algn="ctr"/>
-            <a:r>
-              <a:rPr sz="1300" b="0">
-                <a:solidFill>
-                  <a:srgbClr val="9AA1C0"/>
-                </a:solidFill>
-                <a:latin typeface="Calibri"/>
-              </a:rPr>
-              <a:t>Family-Hub · AGPL open source · github.com/msampath/fam-hub</a:t>
-            </a:r>
           </a:p>
         </p:txBody>
       </p:sp>

</xml_diff>